<commit_message>
Unify naming to Section, refactor generator class, and fix output path duplication (s)
</commit_message>
<xml_diff>
--- a/design-strategy/bank_strategy_presentation.pptx
+++ b/design-strategy/bank_strategy_presentation.pptx
@@ -3178,7 +3178,6 @@
             <a:spAutoFit/>
           </a:bodyPr>
           <a:lstStyle/>
-          <a:p/>
           <a:p>
             <a:pPr algn="ctr">
               <a:defRPr sz="5400" b="1">
@@ -3357,7 +3356,7 @@
               </a:defRPr>
             </a:pPr>
             <a:r>
-              <a:t>CHAPTER 2</a:t>
+              <a:t>Section 02</a:t>
             </a:r>
           </a:p>
         </p:txBody>
@@ -3383,7 +3382,6 @@
             <a:spAutoFit/>
           </a:bodyPr>
           <a:lstStyle/>
-          <a:p/>
           <a:p>
             <a:pPr algn="l">
               <a:defRPr sz="3600" b="1">
@@ -3581,7 +3579,7 @@
               </a:defRPr>
             </a:pPr>
             <a:r>
-              <a:t>CHAPTER 2</a:t>
+              <a:t>Section 02</a:t>
             </a:r>
           </a:p>
         </p:txBody>
@@ -3607,7 +3605,6 @@
             <a:spAutoFit/>
           </a:bodyPr>
           <a:lstStyle/>
-          <a:p/>
           <a:p>
             <a:pPr>
               <a:defRPr sz="2800" b="1">
@@ -3901,7 +3898,7 @@
               </a:defRPr>
             </a:pPr>
             <a:r>
-              <a:t>CHAPTER 2</a:t>
+              <a:t>Section 02</a:t>
             </a:r>
           </a:p>
         </p:txBody>
@@ -3927,7 +3924,6 @@
             <a:spAutoFit/>
           </a:bodyPr>
           <a:lstStyle/>
-          <a:p/>
           <a:p>
             <a:pPr algn="l">
               <a:defRPr sz="3600" b="1">
@@ -4125,7 +4121,7 @@
               </a:defRPr>
             </a:pPr>
             <a:r>
-              <a:t>CHAPTER 2</a:t>
+              <a:t>Section 02</a:t>
             </a:r>
           </a:p>
         </p:txBody>
@@ -4151,7 +4147,6 @@
             <a:spAutoFit/>
           </a:bodyPr>
           <a:lstStyle/>
-          <a:p/>
           <a:p>
             <a:pPr>
               <a:defRPr sz="2800" b="1">
@@ -4457,7 +4452,6 @@
             <a:spAutoFit/>
           </a:bodyPr>
           <a:lstStyle/>
-          <a:p/>
           <a:p>
             <a:pPr algn="ctr">
               <a:defRPr sz="6000" b="1">
@@ -4468,7 +4462,7 @@
               </a:defRPr>
             </a:pPr>
             <a:r>
-              <a:t>SECTION 03</a:t>
+              <a:t>Section 03</a:t>
             </a:r>
           </a:p>
         </p:txBody>
@@ -4494,7 +4488,6 @@
             <a:spAutoFit/>
           </a:bodyPr>
           <a:lstStyle/>
-          <a:p/>
           <a:p>
             <a:pPr algn="ctr">
               <a:defRPr sz="4000" b="1">
@@ -4620,7 +4613,7 @@
               </a:defRPr>
             </a:pPr>
             <a:r>
-              <a:t>CHAPTER 3</a:t>
+              <a:t>Section 03</a:t>
             </a:r>
           </a:p>
         </p:txBody>
@@ -4646,7 +4639,6 @@
             <a:spAutoFit/>
           </a:bodyPr>
           <a:lstStyle/>
-          <a:p/>
           <a:p>
             <a:pPr>
               <a:defRPr sz="2800" b="1">
@@ -5176,7 +5168,7 @@
               </a:defRPr>
             </a:pPr>
             <a:r>
-              <a:t>CHAPTER 3</a:t>
+              <a:t>Section 03</a:t>
             </a:r>
           </a:p>
         </p:txBody>
@@ -5202,7 +5194,6 @@
             <a:spAutoFit/>
           </a:bodyPr>
           <a:lstStyle/>
-          <a:p/>
           <a:p>
             <a:pPr algn="l">
               <a:defRPr sz="3600" b="1">
@@ -5374,7 +5365,6 @@
             <a:spAutoFit/>
           </a:bodyPr>
           <a:lstStyle/>
-          <a:p/>
           <a:p>
             <a:pPr algn="ctr">
               <a:defRPr sz="6000" b="1">
@@ -5385,7 +5375,7 @@
               </a:defRPr>
             </a:pPr>
             <a:r>
-              <a:t>SECTION 04</a:t>
+              <a:t>Section 04</a:t>
             </a:r>
           </a:p>
         </p:txBody>
@@ -5411,7 +5401,6 @@
             <a:spAutoFit/>
           </a:bodyPr>
           <a:lstStyle/>
-          <a:p/>
           <a:p>
             <a:pPr algn="ctr">
               <a:defRPr sz="4000" b="1">
@@ -5537,7 +5526,7 @@
               </a:defRPr>
             </a:pPr>
             <a:r>
-              <a:t>CHAPTER 4</a:t>
+              <a:t>Section 04</a:t>
             </a:r>
           </a:p>
         </p:txBody>
@@ -5563,7 +5552,6 @@
             <a:spAutoFit/>
           </a:bodyPr>
           <a:lstStyle/>
-          <a:p/>
           <a:p>
             <a:pPr algn="l">
               <a:defRPr sz="3600" b="1">
@@ -5761,7 +5749,7 @@
               </a:defRPr>
             </a:pPr>
             <a:r>
-              <a:t>CHAPTER 4</a:t>
+              <a:t>Section 04</a:t>
             </a:r>
           </a:p>
         </p:txBody>
@@ -5787,7 +5775,6 @@
             <a:spAutoFit/>
           </a:bodyPr>
           <a:lstStyle/>
-          <a:p/>
           <a:p>
             <a:pPr algn="l">
               <a:defRPr sz="3600" b="1">
@@ -6011,7 +5998,6 @@
             <a:spAutoFit/>
           </a:bodyPr>
           <a:lstStyle/>
-          <a:p/>
           <a:p>
             <a:pPr algn="l">
               <a:defRPr sz="3600" b="1">
@@ -6187,7 +6173,6 @@
             <a:spAutoFit/>
           </a:bodyPr>
           <a:lstStyle/>
-          <a:p/>
           <a:p>
             <a:pPr algn="ctr">
               <a:defRPr sz="6000" b="1">
@@ -6198,7 +6183,7 @@
               </a:defRPr>
             </a:pPr>
             <a:r>
-              <a:t>SECTION 05</a:t>
+              <a:t>Section 05</a:t>
             </a:r>
           </a:p>
         </p:txBody>
@@ -6224,7 +6209,6 @@
             <a:spAutoFit/>
           </a:bodyPr>
           <a:lstStyle/>
-          <a:p/>
           <a:p>
             <a:pPr algn="ctr">
               <a:defRPr sz="4000" b="1">
@@ -6350,7 +6334,7 @@
               </a:defRPr>
             </a:pPr>
             <a:r>
-              <a:t>CHAPTER 5</a:t>
+              <a:t>Section 05</a:t>
             </a:r>
           </a:p>
         </p:txBody>
@@ -6376,7 +6360,6 @@
             <a:spAutoFit/>
           </a:bodyPr>
           <a:lstStyle/>
-          <a:p/>
           <a:p>
             <a:pPr algn="l">
               <a:defRPr sz="3600" b="1">
@@ -6574,7 +6557,7 @@
               </a:defRPr>
             </a:pPr>
             <a:r>
-              <a:t>CHAPTER 5</a:t>
+              <a:t>Section 05</a:t>
             </a:r>
           </a:p>
         </p:txBody>
@@ -6600,7 +6583,6 @@
             <a:spAutoFit/>
           </a:bodyPr>
           <a:lstStyle/>
-          <a:p/>
           <a:p>
             <a:pPr algn="l">
               <a:defRPr sz="3600" b="1">
@@ -6798,7 +6780,7 @@
               </a:defRPr>
             </a:pPr>
             <a:r>
-              <a:t>CHAPTER 5</a:t>
+              <a:t>Section 05</a:t>
             </a:r>
           </a:p>
         </p:txBody>
@@ -6824,7 +6806,6 @@
             <a:spAutoFit/>
           </a:bodyPr>
           <a:lstStyle/>
-          <a:p/>
           <a:p>
             <a:pPr algn="l">
               <a:defRPr sz="3600" b="1">
@@ -7230,7 +7211,6 @@
             <a:spAutoFit/>
           </a:bodyPr>
           <a:lstStyle/>
-          <a:p/>
           <a:p>
             <a:pPr algn="l">
               <a:defRPr sz="3600" b="1">
@@ -7454,7 +7434,6 @@
             <a:spAutoFit/>
           </a:bodyPr>
           <a:lstStyle/>
-          <a:p/>
           <a:p>
             <a:pPr algn="l">
               <a:defRPr sz="3600" b="1">
@@ -7505,7 +7484,7 @@
               </a:defRPr>
             </a:pPr>
             <a:r>
-              <a:t>• CHAPTER 1: 合併と再編の歴史（なぜメガバンクが生まれたか）</a:t>
+              <a:t>• Section 01: 1. 銀行の歴史（合併・再編）</a:t>
             </a:r>
           </a:p>
           <a:p>
@@ -7521,7 +7500,7 @@
               </a:defRPr>
             </a:pPr>
             <a:r>
-              <a:t>• CHAPTER 2: ビジネスモデルの詳細（信用創造と収益構造）</a:t>
+              <a:t>• Section 02: 2. 銀行の新たなビジネスモデル</a:t>
             </a:r>
           </a:p>
           <a:p>
@@ -7537,7 +7516,7 @@
               </a:defRPr>
             </a:pPr>
             <a:r>
-              <a:t>• CHAPTER 3: 業界の現状とデジタル・シフトの波</a:t>
+              <a:t>• Section 03: 3. 銀行業界の現状</a:t>
             </a:r>
           </a:p>
           <a:p>
@@ -7553,7 +7532,7 @@
               </a:defRPr>
             </a:pPr>
             <a:r>
-              <a:t>• CHAPTER 4: 競合と構造的脅威（GAFAMなどの参入）</a:t>
+              <a:t>• Section 04: 4. 競合・新たな脅威</a:t>
             </a:r>
           </a:p>
           <a:p>
@@ -7569,7 +7548,7 @@
               </a:defRPr>
             </a:pPr>
             <a:r>
-              <a:t>• CHAPTER 5: 2030年代の銀行像（未来への展望）</a:t>
+              <a:t>• Section 05: 5. 銀行の将来・今後の展望</a:t>
             </a:r>
           </a:p>
         </p:txBody>
@@ -7658,7 +7637,6 @@
             <a:spAutoFit/>
           </a:bodyPr>
           <a:lstStyle/>
-          <a:p/>
           <a:p>
             <a:pPr algn="ctr">
               <a:defRPr sz="6000" b="1">
@@ -7669,7 +7647,7 @@
               </a:defRPr>
             </a:pPr>
             <a:r>
-              <a:t>SECTION 01</a:t>
+              <a:t>Section 01</a:t>
             </a:r>
           </a:p>
         </p:txBody>
@@ -7695,7 +7673,6 @@
             <a:spAutoFit/>
           </a:bodyPr>
           <a:lstStyle/>
-          <a:p/>
           <a:p>
             <a:pPr algn="ctr">
               <a:defRPr sz="4000" b="1">
@@ -7821,7 +7798,7 @@
               </a:defRPr>
             </a:pPr>
             <a:r>
-              <a:t>CHAPTER 1</a:t>
+              <a:t>Section 01</a:t>
             </a:r>
           </a:p>
         </p:txBody>
@@ -7847,7 +7824,6 @@
             <a:spAutoFit/>
           </a:bodyPr>
           <a:lstStyle/>
-          <a:p/>
           <a:p>
             <a:pPr>
               <a:defRPr sz="2800" b="1">
@@ -8496,7 +8472,6 @@
             <a:spAutoFit/>
           </a:bodyPr>
           <a:lstStyle/>
-          <a:p/>
           <a:p>
             <a:pPr algn="ctr">
               <a:defRPr sz="6000" b="1">
@@ -8507,7 +8482,7 @@
               </a:defRPr>
             </a:pPr>
             <a:r>
-              <a:t>SECTION 02</a:t>
+              <a:t>Section 02</a:t>
             </a:r>
           </a:p>
         </p:txBody>
@@ -8533,7 +8508,6 @@
             <a:spAutoFit/>
           </a:bodyPr>
           <a:lstStyle/>
-          <a:p/>
           <a:p>
             <a:pPr algn="ctr">
               <a:defRPr sz="4000" b="1">
@@ -8659,7 +8633,7 @@
               </a:defRPr>
             </a:pPr>
             <a:r>
-              <a:t>CHAPTER 2</a:t>
+              <a:t>Section 02</a:t>
             </a:r>
           </a:p>
         </p:txBody>
@@ -8685,7 +8659,6 @@
             <a:spAutoFit/>
           </a:bodyPr>
           <a:lstStyle/>
-          <a:p/>
           <a:p>
             <a:pPr algn="l">
               <a:defRPr sz="3600" b="1">
@@ -8883,7 +8856,7 @@
               </a:defRPr>
             </a:pPr>
             <a:r>
-              <a:t>CHAPTER 2</a:t>
+              <a:t>Section 02</a:t>
             </a:r>
           </a:p>
         </p:txBody>
@@ -8909,7 +8882,6 @@
             <a:spAutoFit/>
           </a:bodyPr>
           <a:lstStyle/>
-          <a:p/>
           <a:p>
             <a:pPr algn="l">
               <a:defRPr sz="3600" b="1">
@@ -9107,7 +9079,7 @@
               </a:defRPr>
             </a:pPr>
             <a:r>
-              <a:t>CHAPTER 2</a:t>
+              <a:t>Section 02</a:t>
             </a:r>
           </a:p>
         </p:txBody>
@@ -9133,7 +9105,6 @@
             <a:spAutoFit/>
           </a:bodyPr>
           <a:lstStyle/>
-          <a:p/>
           <a:p>
             <a:pPr>
               <a:defRPr sz="2800" b="1">

</xml_diff>

<commit_message>
Fix coordinate overflow and diagram overlapping in Strategy presentation (s)
</commit_message>
<xml_diff>
--- a/design-strategy/bank_strategy_presentation.pptx
+++ b/design-strategy/bank_strategy_presentation.pptx
@@ -3193,6 +3193,9 @@
           </a:p>
           <a:p>
             <a:pPr algn="ctr">
+              <a:spcBef>
+                <a:spcPts val="3000"/>
+              </a:spcBef>
               <a:defRPr sz="2400">
                 <a:solidFill>
                   <a:srgbClr val="828282"/>
@@ -3714,16 +3717,16 @@
       </p:sp>
       <p:sp>
         <p:nvSpPr>
-          <p:cNvPr id="7" name="Left Brace 6"/>
+          <p:cNvPr id="7" name="Right Brace 6"/>
           <p:cNvSpPr/>
           <p:nvPr/>
         </p:nvSpPr>
         <p:spPr>
-          <a:xfrm rot="10800000">
+          <a:xfrm>
             <a:off x="8229600" y="1828800"/>
             <a:ext cx="457200" cy="2743200"/>
           </a:xfrm>
-          <a:prstGeom prst="leftBrace">
+          <a:prstGeom prst="rightBrace">
             <a:avLst/>
           </a:prstGeom>
         </p:spPr>
@@ -4338,7 +4341,7 @@
         <p:spPr>
           <a:xfrm>
             <a:off x="3809847" y="4114800"/>
-            <a:ext cx="1828800" cy="914400"/>
+            <a:ext cx="2286000" cy="914400"/>
           </a:xfrm>
           <a:prstGeom prst="rect">
             <a:avLst/>
@@ -4742,13 +4745,7 @@
           <a:bodyPr rtlCol="0" anchor="ctr"/>
           <a:lstStyle/>
           <a:p>
-            <a:pPr algn="l">
-              <a:defRPr>
-                <a:solidFill>
-                  <a:srgbClr val="1C1B19"/>
-                </a:solidFill>
-              </a:defRPr>
-            </a:pPr>
+            <a:pPr algn="l"/>
             <a:r>
               <a:t>日本銀行 (唯一無二)</a:t>
             </a:r>
@@ -4843,13 +4840,7 @@
           <a:bodyPr rtlCol="0" anchor="ctr"/>
           <a:lstStyle/>
           <a:p>
-            <a:pPr algn="l">
-              <a:defRPr>
-                <a:solidFill>
-                  <a:srgbClr val="1C1B19"/>
-                </a:solidFill>
-              </a:defRPr>
-            </a:pPr>
+            <a:pPr algn="l"/>
             <a:r>
               <a:t>メガバンク (全国・海外展開)</a:t>
             </a:r>
@@ -4944,13 +4935,7 @@
           <a:bodyPr rtlCol="0" anchor="ctr"/>
           <a:lstStyle/>
           <a:p>
-            <a:pPr algn="l">
-              <a:defRPr>
-                <a:solidFill>
-                  <a:srgbClr val="1C1B19"/>
-                </a:solidFill>
-              </a:defRPr>
-            </a:pPr>
+            <a:pPr algn="l"/>
             <a:r>
               <a:t>地域密着型 (地元経済の要)</a:t>
             </a:r>
@@ -5045,13 +5030,7 @@
           <a:bodyPr rtlCol="0" anchor="ctr"/>
           <a:lstStyle/>
           <a:p>
-            <a:pPr algn="l">
-              <a:defRPr>
-                <a:solidFill>
-                  <a:srgbClr val="1C1B19"/>
-                </a:solidFill>
-              </a:defRPr>
-            </a:pPr>
+            <a:pPr algn="l"/>
             <a:r>
               <a:t>利便性・低コスト追求</a:t>
             </a:r>
@@ -9186,7 +9165,7 @@
         </p:nvSpPr>
         <p:spPr>
           <a:xfrm>
-            <a:off x="1839481106400" y="3566160"/>
+            <a:off x="2926080" y="3566160"/>
             <a:ext cx="365760" cy="365760"/>
           </a:xfrm>
           <a:prstGeom prst="rightArrow">
@@ -9226,7 +9205,7 @@
         </p:nvSpPr>
         <p:spPr>
           <a:xfrm>
-            <a:off x="2173932050400" y="2743200"/>
+            <a:off x="3291840" y="2743200"/>
             <a:ext cx="2011680" cy="2011680"/>
           </a:xfrm>
           <a:prstGeom prst="rect">
@@ -9284,7 +9263,7 @@
         </p:nvSpPr>
         <p:spPr>
           <a:xfrm>
-            <a:off x="4013412242400" y="3566160"/>
+            <a:off x="5303520" y="3566160"/>
             <a:ext cx="365760" cy="365760"/>
           </a:xfrm>
           <a:prstGeom prst="rightArrow">
@@ -9324,7 +9303,7 @@
         </p:nvSpPr>
         <p:spPr>
           <a:xfrm>
-            <a:off x="4347863186400" y="2743200"/>
+            <a:off x="5669280" y="2743200"/>
             <a:ext cx="2011680" cy="2011680"/>
           </a:xfrm>
           <a:prstGeom prst="rect">
@@ -9382,7 +9361,7 @@
         </p:nvSpPr>
         <p:spPr>
           <a:xfrm>
-            <a:off x="6187343378400" y="3566160"/>
+            <a:off x="7680960" y="3566160"/>
             <a:ext cx="365760" cy="365760"/>
           </a:xfrm>
           <a:prstGeom prst="rightArrow">
@@ -9422,7 +9401,7 @@
         </p:nvSpPr>
         <p:spPr>
           <a:xfrm>
-            <a:off x="6521794322400" y="2743200"/>
+            <a:off x="8046720" y="2743200"/>
             <a:ext cx="2011680" cy="2011680"/>
           </a:xfrm>
           <a:prstGeom prst="ellipse">

</xml_diff>

<commit_message>
Apply visual refinements and language simplification to Strategy presentation (s)
</commit_message>
<xml_diff>
--- a/design-strategy/bank_strategy_presentation.pptx
+++ b/design-strategy/bank_strategy_presentation.pptx
@@ -3425,9 +3425,9 @@
           <a:p>
             <a:pPr>
               <a:spcAft>
-                <a:spcPts val="2000"/>
+                <a:spcPts val="1600"/>
               </a:spcAft>
-              <a:defRPr sz="2400">
+              <a:defRPr sz="2200">
                 <a:solidFill>
                   <a:srgbClr val="1C1B19"/>
                 </a:solidFill>
@@ -3441,9 +3441,9 @@
           <a:p>
             <a:pPr>
               <a:spcAft>
-                <a:spcPts val="2000"/>
+                <a:spcPts val="1600"/>
               </a:spcAft>
-              <a:defRPr sz="2400">
+              <a:defRPr sz="2200">
                 <a:solidFill>
                   <a:srgbClr val="1C1B19"/>
                 </a:solidFill>
@@ -3457,9 +3457,9 @@
           <a:p>
             <a:pPr>
               <a:spcAft>
-                <a:spcPts val="2000"/>
+                <a:spcPts val="1600"/>
               </a:spcAft>
-              <a:defRPr sz="2400">
+              <a:defRPr sz="2200">
                 <a:solidFill>
                   <a:srgbClr val="1C1B19"/>
                 </a:solidFill>
@@ -3638,7 +3638,7 @@
             <a:avLst/>
           </a:prstGeom>
           <a:solidFill>
-            <a:srgbClr val="1C1B19"/>
+            <a:srgbClr val="F9D13E"/>
           </a:solidFill>
         </p:spPr>
         <p:style>
@@ -3660,9 +3660,9 @@
           <a:lstStyle/>
           <a:p>
             <a:pPr algn="ctr">
-              <a:defRPr>
-                <a:solidFill>
-                  <a:srgbClr val="FFFFFF"/>
+              <a:defRPr b="1">
+                <a:solidFill>
+                  <a:srgbClr val="1C1B19"/>
                 </a:solidFill>
               </a:defRPr>
             </a:pPr>
@@ -3674,20 +3674,20 @@
       </p:sp>
       <p:sp>
         <p:nvSpPr>
-          <p:cNvPr id="6" name="Rectangle 5"/>
+          <p:cNvPr id="6" name="Rounded Rectangle 5"/>
           <p:cNvSpPr/>
           <p:nvPr/>
         </p:nvSpPr>
         <p:spPr>
           <a:xfrm>
-            <a:off x="5943600" y="4572000"/>
-            <a:ext cx="1828800" cy="914400"/>
-          </a:xfrm>
-          <a:prstGeom prst="rect">
+            <a:off x="5943600" y="4114800"/>
+            <a:ext cx="1828800" cy="457200"/>
+          </a:xfrm>
+          <a:prstGeom prst="roundRect">
             <a:avLst/>
           </a:prstGeom>
           <a:solidFill>
-            <a:srgbClr val="828282"/>
+            <a:srgbClr val="F9D13E"/>
           </a:solidFill>
         </p:spPr>
         <p:style>
@@ -3708,27 +3708,36 @@
           <a:bodyPr rtlCol="0" anchor="ctr"/>
           <a:lstStyle/>
           <a:p>
-            <a:pPr algn="ctr"/>
-            <a:r>
-              <a:t>預金利息</a:t>
-            </a:r>
-          </a:p>
-        </p:txBody>
-      </p:sp>
-      <p:sp>
-        <p:nvSpPr>
-          <p:cNvPr id="7" name="Right Brace 6"/>
+            <a:pPr algn="ctr">
+              <a:defRPr sz="1200">
+                <a:solidFill>
+                  <a:srgbClr val="1C1B19"/>
+                </a:solidFill>
+              </a:defRPr>
+            </a:pPr>
+            <a:r>
+              <a:t>システム・運営コスト</a:t>
+            </a:r>
+          </a:p>
+        </p:txBody>
+      </p:sp>
+      <p:sp>
+        <p:nvSpPr>
+          <p:cNvPr id="7" name="Rectangle 6"/>
           <p:cNvSpPr/>
           <p:nvPr/>
         </p:nvSpPr>
         <p:spPr>
           <a:xfrm>
-            <a:off x="8229600" y="1828800"/>
-            <a:ext cx="457200" cy="2743200"/>
-          </a:xfrm>
-          <a:prstGeom prst="rightBrace">
+            <a:off x="5943600" y="4572000"/>
+            <a:ext cx="1828800" cy="914400"/>
+          </a:xfrm>
+          <a:prstGeom prst="rect">
             <a:avLst/>
           </a:prstGeom>
+          <a:solidFill>
+            <a:srgbClr val="828282"/>
+          </a:solidFill>
         </p:spPr>
         <p:style>
           <a:lnRef idx="1">
@@ -3749,12 +3758,52 @@
           <a:lstStyle/>
           <a:p>
             <a:pPr algn="ctr"/>
-          </a:p>
-        </p:txBody>
-      </p:sp>
-      <p:sp>
-        <p:nvSpPr>
-          <p:cNvPr id="8" name="TextBox 7"/>
+            <a:r>
+              <a:t>預金利息</a:t>
+            </a:r>
+          </a:p>
+        </p:txBody>
+      </p:sp>
+      <p:sp>
+        <p:nvSpPr>
+          <p:cNvPr id="8" name="Right Brace 7"/>
+          <p:cNvSpPr/>
+          <p:nvPr/>
+        </p:nvSpPr>
+        <p:spPr>
+          <a:xfrm>
+            <a:off x="8229600" y="1828800"/>
+            <a:ext cx="457200" cy="2743200"/>
+          </a:xfrm>
+          <a:prstGeom prst="rightBrace">
+            <a:avLst/>
+          </a:prstGeom>
+        </p:spPr>
+        <p:style>
+          <a:lnRef idx="1">
+            <a:schemeClr val="accent1"/>
+          </a:lnRef>
+          <a:fillRef idx="3">
+            <a:schemeClr val="accent1"/>
+          </a:fillRef>
+          <a:effectRef idx="2">
+            <a:schemeClr val="accent1"/>
+          </a:effectRef>
+          <a:fontRef idx="minor">
+            <a:schemeClr val="lt1"/>
+          </a:fontRef>
+        </p:style>
+        <p:txBody>
+          <a:bodyPr rtlCol="0" anchor="ctr"/>
+          <a:lstStyle/>
+          <a:p>
+            <a:pPr algn="ctr"/>
+          </a:p>
+        </p:txBody>
+      </p:sp>
+      <p:sp>
+        <p:nvSpPr>
+          <p:cNvPr id="9" name="TextBox 8"/>
           <p:cNvSpPr txBox="1"/>
           <p:nvPr/>
         </p:nvSpPr>
@@ -3967,9 +4016,9 @@
           <a:p>
             <a:pPr>
               <a:spcAft>
-                <a:spcPts val="2000"/>
+                <a:spcPts val="1600"/>
               </a:spcAft>
-              <a:defRPr sz="2400">
+              <a:defRPr sz="2200">
                 <a:solidFill>
                   <a:srgbClr val="1C1B19"/>
                 </a:solidFill>
@@ -3983,9 +4032,9 @@
           <a:p>
             <a:pPr>
               <a:spcAft>
-                <a:spcPts val="2000"/>
+                <a:spcPts val="1600"/>
               </a:spcAft>
-              <a:defRPr sz="2400">
+              <a:defRPr sz="2200">
                 <a:solidFill>
                   <a:srgbClr val="1C1B19"/>
                 </a:solidFill>
@@ -3999,9 +4048,9 @@
           <a:p>
             <a:pPr>
               <a:spcAft>
-                <a:spcPts val="2000"/>
+                <a:spcPts val="1600"/>
               </a:spcAft>
-              <a:defRPr sz="2400">
+              <a:defRPr sz="2200">
                 <a:solidFill>
                   <a:srgbClr val="1C1B19"/>
                 </a:solidFill>
@@ -4340,8 +4389,8 @@
         </p:nvSpPr>
         <p:spPr>
           <a:xfrm>
-            <a:off x="3809847" y="4114800"/>
-            <a:ext cx="2286000" cy="914400"/>
+            <a:off x="1066647" y="6126480"/>
+            <a:ext cx="4572000" cy="457200"/>
           </a:xfrm>
           <a:prstGeom prst="rect">
             <a:avLst/>
@@ -4355,18 +4404,14 @@
           <a:lstStyle/>
           <a:p>
             <a:pPr>
-              <a:defRPr sz="1400">
+              <a:defRPr sz="1600" b="1">
                 <a:solidFill>
                   <a:srgbClr val="FF0000"/>
                 </a:solidFill>
               </a:defRPr>
             </a:pPr>
             <a:r>
-              <a:t>★預金は「預かりもの」</a:t>
-            </a:r>
-            <a:br/>
-            <a:r>
-              <a:t>であり負債となる</a:t>
+              <a:t>★銀行にとって、預金は「預かりもの」であり負債となる</a:t>
             </a:r>
           </a:p>
         </p:txBody>
@@ -4745,7 +4790,13 @@
           <a:bodyPr rtlCol="0" anchor="ctr"/>
           <a:lstStyle/>
           <a:p>
-            <a:pPr algn="l"/>
+            <a:pPr algn="l">
+              <a:defRPr>
+                <a:solidFill>
+                  <a:srgbClr val="1C1B19"/>
+                </a:solidFill>
+              </a:defRPr>
+            </a:pPr>
             <a:r>
               <a:t>日本銀行 (唯一無二)</a:t>
             </a:r>
@@ -4840,7 +4891,13 @@
           <a:bodyPr rtlCol="0" anchor="ctr"/>
           <a:lstStyle/>
           <a:p>
-            <a:pPr algn="l"/>
+            <a:pPr algn="l">
+              <a:defRPr>
+                <a:solidFill>
+                  <a:srgbClr val="1C1B19"/>
+                </a:solidFill>
+              </a:defRPr>
+            </a:pPr>
             <a:r>
               <a:t>メガバンク (全国・海外展開)</a:t>
             </a:r>
@@ -4935,7 +4992,13 @@
           <a:bodyPr rtlCol="0" anchor="ctr"/>
           <a:lstStyle/>
           <a:p>
-            <a:pPr algn="l"/>
+            <a:pPr algn="l">
+              <a:defRPr>
+                <a:solidFill>
+                  <a:srgbClr val="1C1B19"/>
+                </a:solidFill>
+              </a:defRPr>
+            </a:pPr>
             <a:r>
               <a:t>地域密着型 (地元経済の要)</a:t>
             </a:r>
@@ -5030,7 +5093,13 @@
           <a:bodyPr rtlCol="0" anchor="ctr"/>
           <a:lstStyle/>
           <a:p>
-            <a:pPr algn="l"/>
+            <a:pPr algn="l">
+              <a:defRPr>
+                <a:solidFill>
+                  <a:srgbClr val="1C1B19"/>
+                </a:solidFill>
+              </a:defRPr>
+            </a:pPr>
             <a:r>
               <a:t>利便性・低コスト追求</a:t>
             </a:r>
@@ -5213,9 +5282,9 @@
           <a:p>
             <a:pPr>
               <a:spcAft>
-                <a:spcPts val="2000"/>
+                <a:spcPts val="1600"/>
               </a:spcAft>
-              <a:defRPr sz="2400">
+              <a:defRPr sz="2200">
                 <a:solidFill>
                   <a:srgbClr val="1C1B19"/>
                 </a:solidFill>
@@ -5229,9 +5298,9 @@
           <a:p>
             <a:pPr>
               <a:spcAft>
-                <a:spcPts val="2000"/>
+                <a:spcPts val="1600"/>
               </a:spcAft>
-              <a:defRPr sz="2400">
+              <a:defRPr sz="2200">
                 <a:solidFill>
                   <a:srgbClr val="1C1B19"/>
                 </a:solidFill>
@@ -5245,9 +5314,9 @@
           <a:p>
             <a:pPr>
               <a:spcAft>
-                <a:spcPts val="2000"/>
+                <a:spcPts val="1600"/>
               </a:spcAft>
-              <a:defRPr sz="2400">
+              <a:defRPr sz="2200">
                 <a:solidFill>
                   <a:srgbClr val="1C1B19"/>
                 </a:solidFill>
@@ -5571,9 +5640,9 @@
           <a:p>
             <a:pPr>
               <a:spcAft>
-                <a:spcPts val="2000"/>
+                <a:spcPts val="1600"/>
               </a:spcAft>
-              <a:defRPr sz="2400">
+              <a:defRPr sz="2200">
                 <a:solidFill>
                   <a:srgbClr val="1C1B19"/>
                 </a:solidFill>
@@ -5587,9 +5656,9 @@
           <a:p>
             <a:pPr>
               <a:spcAft>
-                <a:spcPts val="2000"/>
+                <a:spcPts val="1600"/>
               </a:spcAft>
-              <a:defRPr sz="2400">
+              <a:defRPr sz="2200">
                 <a:solidFill>
                   <a:srgbClr val="1C1B19"/>
                 </a:solidFill>
@@ -5603,9 +5672,9 @@
           <a:p>
             <a:pPr>
               <a:spcAft>
-                <a:spcPts val="2000"/>
+                <a:spcPts val="1600"/>
               </a:spcAft>
-              <a:defRPr sz="2400">
+              <a:defRPr sz="2200">
                 <a:solidFill>
                   <a:srgbClr val="1C1B19"/>
                 </a:solidFill>
@@ -5764,7 +5833,7 @@
               </a:defRPr>
             </a:pPr>
             <a:r>
-              <a:t>異業種参入：Embedded Finance（組み込み金融）</a:t>
+              <a:t>異業種参入：あらゆるサービスへの金融機能の融合</a:t>
             </a:r>
           </a:p>
         </p:txBody>
@@ -5794,9 +5863,9 @@
           <a:p>
             <a:pPr>
               <a:spcAft>
-                <a:spcPts val="2000"/>
+                <a:spcPts val="1600"/>
               </a:spcAft>
-              <a:defRPr sz="2400">
+              <a:defRPr sz="2200">
                 <a:solidFill>
                   <a:srgbClr val="1C1B19"/>
                 </a:solidFill>
@@ -5804,15 +5873,15 @@
               </a:defRPr>
             </a:pPr>
             <a:r>
-              <a:t>• 『銀行に行く』という行為の消失。あらゆるサービスに金融が溶け込む。</a:t>
+              <a:t>• 『銀行に行く』という行為の消失。生活のあらゆる場面に金融が溶け込む。</a:t>
             </a:r>
           </a:p>
           <a:p>
             <a:pPr>
               <a:spcAft>
-                <a:spcPts val="2000"/>
+                <a:spcPts val="1600"/>
               </a:spcAft>
-              <a:defRPr sz="2400">
+              <a:defRPr sz="2200">
                 <a:solidFill>
                   <a:srgbClr val="1C1B19"/>
                 </a:solidFill>
@@ -5820,15 +5889,15 @@
               </a:defRPr>
             </a:pPr>
             <a:r>
-              <a:t>• スターバックスやAppleが、実質的な金融機能を提供。</a:t>
+              <a:t>• スターバックスやAppleが、自社の顧客向けに便利な金融サービスを提供。</a:t>
             </a:r>
           </a:p>
           <a:p>
             <a:pPr>
               <a:spcAft>
-                <a:spcPts val="2000"/>
+                <a:spcPts val="1600"/>
               </a:spcAft>
-              <a:defRPr sz="2400">
+              <a:defRPr sz="2200">
                 <a:solidFill>
                   <a:srgbClr val="1C1B19"/>
                 </a:solidFill>
@@ -5836,7 +5905,7 @@
               </a:defRPr>
             </a:pPr>
             <a:r>
-              <a:t>• 伝統的銀行から顧客（データと接点）が奪われる『中抜き』の発生。</a:t>
+              <a:t>• 伝統的銀行から、顧客との接点が奪われる『中抜き』の発生。</a:t>
             </a:r>
           </a:p>
         </p:txBody>
@@ -6021,9 +6090,9 @@
           <a:p>
             <a:pPr>
               <a:spcAft>
-                <a:spcPts val="2000"/>
+                <a:spcPts val="1600"/>
               </a:spcAft>
-              <a:defRPr sz="2400">
+              <a:defRPr sz="2200">
                 <a:solidFill>
                   <a:srgbClr val="1C1B19"/>
                 </a:solidFill>
@@ -6037,9 +6106,9 @@
           <a:p>
             <a:pPr>
               <a:spcAft>
-                <a:spcPts val="2000"/>
+                <a:spcPts val="1600"/>
               </a:spcAft>
-              <a:defRPr sz="2400">
+              <a:defRPr sz="2200">
                 <a:solidFill>
                   <a:srgbClr val="1C1B19"/>
                 </a:solidFill>
@@ -6053,9 +6122,9 @@
           <a:p>
             <a:pPr>
               <a:spcAft>
-                <a:spcPts val="2000"/>
+                <a:spcPts val="1600"/>
               </a:spcAft>
-              <a:defRPr sz="2400">
+              <a:defRPr sz="2200">
                 <a:solidFill>
                   <a:srgbClr val="1C1B19"/>
                 </a:solidFill>
@@ -6379,9 +6448,9 @@
           <a:p>
             <a:pPr>
               <a:spcAft>
-                <a:spcPts val="2000"/>
+                <a:spcPts val="1600"/>
               </a:spcAft>
-              <a:defRPr sz="2400">
+              <a:defRPr sz="2200">
                 <a:solidFill>
                   <a:srgbClr val="1C1B19"/>
                 </a:solidFill>
@@ -6395,9 +6464,9 @@
           <a:p>
             <a:pPr>
               <a:spcAft>
-                <a:spcPts val="2000"/>
+                <a:spcPts val="1600"/>
               </a:spcAft>
-              <a:defRPr sz="2400">
+              <a:defRPr sz="2200">
                 <a:solidFill>
                   <a:srgbClr val="1C1B19"/>
                 </a:solidFill>
@@ -6411,9 +6480,9 @@
           <a:p>
             <a:pPr>
               <a:spcAft>
-                <a:spcPts val="2000"/>
+                <a:spcPts val="1600"/>
               </a:spcAft>
-              <a:defRPr sz="2400">
+              <a:defRPr sz="2200">
                 <a:solidFill>
                   <a:srgbClr val="1C1B19"/>
                 </a:solidFill>
@@ -6602,9 +6671,9 @@
           <a:p>
             <a:pPr>
               <a:spcAft>
-                <a:spcPts val="2000"/>
+                <a:spcPts val="1600"/>
               </a:spcAft>
-              <a:defRPr sz="2400">
+              <a:defRPr sz="2200">
                 <a:solidFill>
                   <a:srgbClr val="1C1B19"/>
                 </a:solidFill>
@@ -6618,9 +6687,9 @@
           <a:p>
             <a:pPr>
               <a:spcAft>
-                <a:spcPts val="2000"/>
+                <a:spcPts val="1600"/>
               </a:spcAft>
-              <a:defRPr sz="2400">
+              <a:defRPr sz="2200">
                 <a:solidFill>
                   <a:srgbClr val="1C1B19"/>
                 </a:solidFill>
@@ -6634,9 +6703,9 @@
           <a:p>
             <a:pPr>
               <a:spcAft>
-                <a:spcPts val="2000"/>
+                <a:spcPts val="1600"/>
               </a:spcAft>
-              <a:defRPr sz="2400">
+              <a:defRPr sz="2200">
                 <a:solidFill>
                   <a:srgbClr val="1C1B19"/>
                 </a:solidFill>
@@ -6825,9 +6894,9 @@
           <a:p>
             <a:pPr>
               <a:spcAft>
-                <a:spcPts val="2000"/>
+                <a:spcPts val="1600"/>
               </a:spcAft>
-              <a:defRPr sz="2400">
+              <a:defRPr sz="2200">
                 <a:solidFill>
                   <a:srgbClr val="1C1B19"/>
                 </a:solidFill>
@@ -6841,9 +6910,9 @@
           <a:p>
             <a:pPr>
               <a:spcAft>
-                <a:spcPts val="2000"/>
+                <a:spcPts val="1600"/>
               </a:spcAft>
-              <a:defRPr sz="2400">
+              <a:defRPr sz="2200">
                 <a:solidFill>
                   <a:srgbClr val="1C1B19"/>
                 </a:solidFill>
@@ -6857,9 +6926,9 @@
           <a:p>
             <a:pPr>
               <a:spcAft>
-                <a:spcPts val="2000"/>
+                <a:spcPts val="1600"/>
               </a:spcAft>
-              <a:defRPr sz="2400">
+              <a:defRPr sz="2200">
                 <a:solidFill>
                   <a:srgbClr val="1C1B19"/>
                 </a:solidFill>
@@ -7230,9 +7299,9 @@
           <a:p>
             <a:pPr>
               <a:spcAft>
-                <a:spcPts val="2000"/>
+                <a:spcPts val="1600"/>
               </a:spcAft>
-              <a:defRPr sz="2400">
+              <a:defRPr sz="2200">
                 <a:solidFill>
                   <a:srgbClr val="1C1B19"/>
                 </a:solidFill>
@@ -7246,9 +7315,9 @@
           <a:p>
             <a:pPr>
               <a:spcAft>
-                <a:spcPts val="2000"/>
+                <a:spcPts val="1600"/>
               </a:spcAft>
-              <a:defRPr sz="2400">
+              <a:defRPr sz="2200">
                 <a:solidFill>
                   <a:srgbClr val="1C1B19"/>
                 </a:solidFill>
@@ -7262,9 +7331,9 @@
           <a:p>
             <a:pPr>
               <a:spcAft>
-                <a:spcPts val="2000"/>
+                <a:spcPts val="1600"/>
               </a:spcAft>
-              <a:defRPr sz="2400">
+              <a:defRPr sz="2200">
                 <a:solidFill>
                   <a:srgbClr val="1C1B19"/>
                 </a:solidFill>
@@ -7453,9 +7522,9 @@
           <a:p>
             <a:pPr>
               <a:spcAft>
-                <a:spcPts val="2000"/>
+                <a:spcPts val="1600"/>
               </a:spcAft>
-              <a:defRPr sz="2400">
+              <a:defRPr sz="2200">
                 <a:solidFill>
                   <a:srgbClr val="1C1B19"/>
                 </a:solidFill>
@@ -7469,9 +7538,9 @@
           <a:p>
             <a:pPr>
               <a:spcAft>
-                <a:spcPts val="2000"/>
+                <a:spcPts val="1600"/>
               </a:spcAft>
-              <a:defRPr sz="2400">
+              <a:defRPr sz="2200">
                 <a:solidFill>
                   <a:srgbClr val="1C1B19"/>
                 </a:solidFill>
@@ -7485,9 +7554,9 @@
           <a:p>
             <a:pPr>
               <a:spcAft>
-                <a:spcPts val="2000"/>
+                <a:spcPts val="1600"/>
               </a:spcAft>
-              <a:defRPr sz="2400">
+              <a:defRPr sz="2200">
                 <a:solidFill>
                   <a:srgbClr val="1C1B19"/>
                 </a:solidFill>
@@ -7501,9 +7570,9 @@
           <a:p>
             <a:pPr>
               <a:spcAft>
-                <a:spcPts val="2000"/>
+                <a:spcPts val="1600"/>
               </a:spcAft>
-              <a:defRPr sz="2400">
+              <a:defRPr sz="2200">
                 <a:solidFill>
                   <a:srgbClr val="1C1B19"/>
                 </a:solidFill>
@@ -7517,9 +7586,9 @@
           <a:p>
             <a:pPr>
               <a:spcAft>
-                <a:spcPts val="2000"/>
+                <a:spcPts val="1600"/>
               </a:spcAft>
-              <a:defRPr sz="2400">
+              <a:defRPr sz="2200">
                 <a:solidFill>
                   <a:srgbClr val="1C1B19"/>
                 </a:solidFill>
@@ -8678,9 +8747,9 @@
           <a:p>
             <a:pPr>
               <a:spcAft>
-                <a:spcPts val="2000"/>
+                <a:spcPts val="1600"/>
               </a:spcAft>
-              <a:defRPr sz="2400">
+              <a:defRPr sz="2200">
                 <a:solidFill>
                   <a:srgbClr val="1C1B19"/>
                 </a:solidFill>
@@ -8694,9 +8763,9 @@
           <a:p>
             <a:pPr>
               <a:spcAft>
-                <a:spcPts val="2000"/>
+                <a:spcPts val="1600"/>
               </a:spcAft>
-              <a:defRPr sz="2400">
+              <a:defRPr sz="2200">
                 <a:solidFill>
                   <a:srgbClr val="1C1B19"/>
                 </a:solidFill>
@@ -8710,9 +8779,9 @@
           <a:p>
             <a:pPr>
               <a:spcAft>
-                <a:spcPts val="2000"/>
+                <a:spcPts val="1600"/>
               </a:spcAft>
-              <a:defRPr sz="2400">
+              <a:defRPr sz="2200">
                 <a:solidFill>
                   <a:srgbClr val="1C1B19"/>
                 </a:solidFill>
@@ -8901,9 +8970,9 @@
           <a:p>
             <a:pPr>
               <a:spcAft>
-                <a:spcPts val="2000"/>
+                <a:spcPts val="1600"/>
               </a:spcAft>
-              <a:defRPr sz="2400">
+              <a:defRPr sz="2200">
                 <a:solidFill>
                   <a:srgbClr val="1C1B19"/>
                 </a:solidFill>
@@ -8917,9 +8986,9 @@
           <a:p>
             <a:pPr>
               <a:spcAft>
-                <a:spcPts val="2000"/>
+                <a:spcPts val="1600"/>
               </a:spcAft>
-              <a:defRPr sz="2400">
+              <a:defRPr sz="2200">
                 <a:solidFill>
                   <a:srgbClr val="1C1B19"/>
                 </a:solidFill>
@@ -8933,9 +9002,9 @@
           <a:p>
             <a:pPr>
               <a:spcAft>
-                <a:spcPts val="2000"/>
+                <a:spcPts val="1600"/>
               </a:spcAft>
-              <a:defRPr sz="2400">
+              <a:defRPr sz="2200">
                 <a:solidFill>
                   <a:srgbClr val="1C1B19"/>
                 </a:solidFill>

</xml_diff>

<commit_message>
Finalized Strategy presentation with balanced layouts, light blue margin box, and simplified terminology
</commit_message>
<xml_diff>
--- a/design-strategy/bank_strategy_presentation.pptx
+++ b/design-strategy/bank_strategy_presentation.pptx
@@ -3408,8 +3408,8 @@
         </p:nvSpPr>
         <p:spPr>
           <a:xfrm>
-            <a:off x="1371600" y="2926080"/>
-            <a:ext cx="9144000" cy="3200400"/>
+            <a:off x="731520" y="2926080"/>
+            <a:ext cx="10515600" cy="3200400"/>
           </a:xfrm>
           <a:prstGeom prst="rect">
             <a:avLst/>
@@ -3417,7 +3417,7 @@
           <a:noFill/>
         </p:spPr>
         <p:txBody>
-          <a:bodyPr wrap="none" anchor="t">
+          <a:bodyPr wrap="square" anchor="t">
             <a:spAutoFit/>
           </a:bodyPr>
           <a:lstStyle/>
@@ -3425,9 +3425,9 @@
           <a:p>
             <a:pPr>
               <a:spcAft>
-                <a:spcPts val="1600"/>
+                <a:spcPts val="1400"/>
               </a:spcAft>
-              <a:defRPr sz="2200">
+              <a:defRPr sz="2100">
                 <a:solidFill>
                   <a:srgbClr val="1C1B19"/>
                 </a:solidFill>
@@ -3441,9 +3441,9 @@
           <a:p>
             <a:pPr>
               <a:spcAft>
-                <a:spcPts val="1600"/>
+                <a:spcPts val="1400"/>
               </a:spcAft>
-              <a:defRPr sz="2200">
+              <a:defRPr sz="2100">
                 <a:solidFill>
                   <a:srgbClr val="1C1B19"/>
                 </a:solidFill>
@@ -3457,9 +3457,9 @@
           <a:p>
             <a:pPr>
               <a:spcAft>
-                <a:spcPts val="1600"/>
+                <a:spcPts val="1400"/>
               </a:spcAft>
-              <a:defRPr sz="2200">
+              <a:defRPr sz="2100">
                 <a:solidFill>
                   <a:srgbClr val="1C1B19"/>
                 </a:solidFill>
@@ -3674,21 +3674,26 @@
       </p:sp>
       <p:sp>
         <p:nvSpPr>
-          <p:cNvPr id="6" name="Rounded Rectangle 5"/>
+          <p:cNvPr id="6" name="Rectangle 5"/>
           <p:cNvSpPr/>
           <p:nvPr/>
         </p:nvSpPr>
         <p:spPr>
           <a:xfrm>
-            <a:off x="5943600" y="4114800"/>
-            <a:ext cx="1828800" cy="457200"/>
-          </a:xfrm>
-          <a:prstGeom prst="roundRect">
+            <a:off x="5943600" y="1828800"/>
+            <a:ext cx="1828800" cy="2743200"/>
+          </a:xfrm>
+          <a:prstGeom prst="rect">
             <a:avLst/>
           </a:prstGeom>
           <a:solidFill>
-            <a:srgbClr val="F9D13E"/>
+            <a:srgbClr val="ADD8E6"/>
           </a:solidFill>
+          <a:ln w="12700">
+            <a:solidFill>
+              <a:srgbClr val="1C1B19"/>
+            </a:solidFill>
+          </a:ln>
         </p:spPr>
         <p:style>
           <a:lnRef idx="1">
@@ -3709,14 +3714,14 @@
           <a:lstStyle/>
           <a:p>
             <a:pPr algn="ctr">
-              <a:defRPr sz="1200">
+              <a:defRPr sz="1400" b="1">
                 <a:solidFill>
                   <a:srgbClr val="1C1B19"/>
                 </a:solidFill>
               </a:defRPr>
             </a:pPr>
             <a:r>
-              <a:t>システム・運営コスト</a:t>
+              <a:t>銀行の収益 (利ざや)</a:t>
             </a:r>
           </a:p>
         </p:txBody>
@@ -3999,8 +4004,8 @@
         </p:nvSpPr>
         <p:spPr>
           <a:xfrm>
-            <a:off x="1371600" y="2926080"/>
-            <a:ext cx="9144000" cy="3200400"/>
+            <a:off x="731520" y="2926080"/>
+            <a:ext cx="10515600" cy="3200400"/>
           </a:xfrm>
           <a:prstGeom prst="rect">
             <a:avLst/>
@@ -4008,7 +4013,7 @@
           <a:noFill/>
         </p:spPr>
         <p:txBody>
-          <a:bodyPr wrap="none" anchor="t">
+          <a:bodyPr wrap="square" anchor="t">
             <a:spAutoFit/>
           </a:bodyPr>
           <a:lstStyle/>
@@ -4016,9 +4021,9 @@
           <a:p>
             <a:pPr>
               <a:spcAft>
-                <a:spcPts val="1600"/>
+                <a:spcPts val="1400"/>
               </a:spcAft>
-              <a:defRPr sz="2200">
+              <a:defRPr sz="2100">
                 <a:solidFill>
                   <a:srgbClr val="1C1B19"/>
                 </a:solidFill>
@@ -4032,9 +4037,9 @@
           <a:p>
             <a:pPr>
               <a:spcAft>
-                <a:spcPts val="1600"/>
+                <a:spcPts val="1400"/>
               </a:spcAft>
-              <a:defRPr sz="2200">
+              <a:defRPr sz="2100">
                 <a:solidFill>
                   <a:srgbClr val="1C1B19"/>
                 </a:solidFill>
@@ -4048,9 +4053,9 @@
           <a:p>
             <a:pPr>
               <a:spcAft>
-                <a:spcPts val="1600"/>
+                <a:spcPts val="1400"/>
               </a:spcAft>
-              <a:defRPr sz="2200">
+              <a:defRPr sz="2100">
                 <a:solidFill>
                   <a:srgbClr val="1C1B19"/>
                 </a:solidFill>
@@ -5265,8 +5270,8 @@
         </p:nvSpPr>
         <p:spPr>
           <a:xfrm>
-            <a:off x="1371600" y="2926080"/>
-            <a:ext cx="9144000" cy="3200400"/>
+            <a:off x="731520" y="2926080"/>
+            <a:ext cx="10515600" cy="3200400"/>
           </a:xfrm>
           <a:prstGeom prst="rect">
             <a:avLst/>
@@ -5274,7 +5279,7 @@
           <a:noFill/>
         </p:spPr>
         <p:txBody>
-          <a:bodyPr wrap="none" anchor="t">
+          <a:bodyPr wrap="square" anchor="t">
             <a:spAutoFit/>
           </a:bodyPr>
           <a:lstStyle/>
@@ -5282,9 +5287,9 @@
           <a:p>
             <a:pPr>
               <a:spcAft>
-                <a:spcPts val="1600"/>
+                <a:spcPts val="1400"/>
               </a:spcAft>
-              <a:defRPr sz="2200">
+              <a:defRPr sz="2100">
                 <a:solidFill>
                   <a:srgbClr val="1C1B19"/>
                 </a:solidFill>
@@ -5298,9 +5303,9 @@
           <a:p>
             <a:pPr>
               <a:spcAft>
-                <a:spcPts val="1600"/>
+                <a:spcPts val="1400"/>
               </a:spcAft>
-              <a:defRPr sz="2200">
+              <a:defRPr sz="2100">
                 <a:solidFill>
                   <a:srgbClr val="1C1B19"/>
                 </a:solidFill>
@@ -5314,9 +5319,9 @@
           <a:p>
             <a:pPr>
               <a:spcAft>
-                <a:spcPts val="1600"/>
+                <a:spcPts val="1400"/>
               </a:spcAft>
-              <a:defRPr sz="2200">
+              <a:defRPr sz="2100">
                 <a:solidFill>
                   <a:srgbClr val="1C1B19"/>
                 </a:solidFill>
@@ -5623,8 +5628,8 @@
         </p:nvSpPr>
         <p:spPr>
           <a:xfrm>
-            <a:off x="1371600" y="2926080"/>
-            <a:ext cx="9144000" cy="3200400"/>
+            <a:off x="731520" y="2926080"/>
+            <a:ext cx="10515600" cy="3200400"/>
           </a:xfrm>
           <a:prstGeom prst="rect">
             <a:avLst/>
@@ -5632,7 +5637,7 @@
           <a:noFill/>
         </p:spPr>
         <p:txBody>
-          <a:bodyPr wrap="none" anchor="t">
+          <a:bodyPr wrap="square" anchor="t">
             <a:spAutoFit/>
           </a:bodyPr>
           <a:lstStyle/>
@@ -5640,9 +5645,9 @@
           <a:p>
             <a:pPr>
               <a:spcAft>
-                <a:spcPts val="1600"/>
+                <a:spcPts val="1400"/>
               </a:spcAft>
-              <a:defRPr sz="2200">
+              <a:defRPr sz="2100">
                 <a:solidFill>
                   <a:srgbClr val="1C1B19"/>
                 </a:solidFill>
@@ -5656,9 +5661,9 @@
           <a:p>
             <a:pPr>
               <a:spcAft>
-                <a:spcPts val="1600"/>
+                <a:spcPts val="1400"/>
               </a:spcAft>
-              <a:defRPr sz="2200">
+              <a:defRPr sz="2100">
                 <a:solidFill>
                   <a:srgbClr val="1C1B19"/>
                 </a:solidFill>
@@ -5672,9 +5677,9 @@
           <a:p>
             <a:pPr>
               <a:spcAft>
-                <a:spcPts val="1600"/>
+                <a:spcPts val="1400"/>
               </a:spcAft>
-              <a:defRPr sz="2200">
+              <a:defRPr sz="2100">
                 <a:solidFill>
                   <a:srgbClr val="1C1B19"/>
                 </a:solidFill>
@@ -5846,8 +5851,8 @@
         </p:nvSpPr>
         <p:spPr>
           <a:xfrm>
-            <a:off x="1371600" y="2926080"/>
-            <a:ext cx="9144000" cy="3200400"/>
+            <a:off x="731520" y="2926080"/>
+            <a:ext cx="10515600" cy="3200400"/>
           </a:xfrm>
           <a:prstGeom prst="rect">
             <a:avLst/>
@@ -5855,7 +5860,7 @@
           <a:noFill/>
         </p:spPr>
         <p:txBody>
-          <a:bodyPr wrap="none" anchor="t">
+          <a:bodyPr wrap="square" anchor="t">
             <a:spAutoFit/>
           </a:bodyPr>
           <a:lstStyle/>
@@ -5863,9 +5868,9 @@
           <a:p>
             <a:pPr>
               <a:spcAft>
-                <a:spcPts val="1600"/>
+                <a:spcPts val="1400"/>
               </a:spcAft>
-              <a:defRPr sz="2200">
+              <a:defRPr sz="2100">
                 <a:solidFill>
                   <a:srgbClr val="1C1B19"/>
                 </a:solidFill>
@@ -5879,9 +5884,9 @@
           <a:p>
             <a:pPr>
               <a:spcAft>
-                <a:spcPts val="1600"/>
+                <a:spcPts val="1400"/>
               </a:spcAft>
-              <a:defRPr sz="2200">
+              <a:defRPr sz="2100">
                 <a:solidFill>
                   <a:srgbClr val="1C1B19"/>
                 </a:solidFill>
@@ -5895,9 +5900,9 @@
           <a:p>
             <a:pPr>
               <a:spcAft>
-                <a:spcPts val="1600"/>
+                <a:spcPts val="1400"/>
               </a:spcAft>
-              <a:defRPr sz="2200">
+              <a:defRPr sz="2100">
                 <a:solidFill>
                   <a:srgbClr val="1C1B19"/>
                 </a:solidFill>
@@ -6073,8 +6078,8 @@
         </p:nvSpPr>
         <p:spPr>
           <a:xfrm>
-            <a:off x="1371600" y="2926080"/>
-            <a:ext cx="9144000" cy="3200400"/>
+            <a:off x="731520" y="2926080"/>
+            <a:ext cx="10515600" cy="3200400"/>
           </a:xfrm>
           <a:prstGeom prst="rect">
             <a:avLst/>
@@ -6082,7 +6087,7 @@
           <a:noFill/>
         </p:spPr>
         <p:txBody>
-          <a:bodyPr wrap="none" anchor="t">
+          <a:bodyPr wrap="square" anchor="t">
             <a:spAutoFit/>
           </a:bodyPr>
           <a:lstStyle/>
@@ -6090,9 +6095,9 @@
           <a:p>
             <a:pPr>
               <a:spcAft>
-                <a:spcPts val="1600"/>
+                <a:spcPts val="1400"/>
               </a:spcAft>
-              <a:defRPr sz="2200">
+              <a:defRPr sz="2100">
                 <a:solidFill>
                   <a:srgbClr val="1C1B19"/>
                 </a:solidFill>
@@ -6106,9 +6111,9 @@
           <a:p>
             <a:pPr>
               <a:spcAft>
-                <a:spcPts val="1600"/>
+                <a:spcPts val="1400"/>
               </a:spcAft>
-              <a:defRPr sz="2200">
+              <a:defRPr sz="2100">
                 <a:solidFill>
                   <a:srgbClr val="1C1B19"/>
                 </a:solidFill>
@@ -6122,9 +6127,9 @@
           <a:p>
             <a:pPr>
               <a:spcAft>
-                <a:spcPts val="1600"/>
+                <a:spcPts val="1400"/>
               </a:spcAft>
-              <a:defRPr sz="2200">
+              <a:defRPr sz="2100">
                 <a:solidFill>
                   <a:srgbClr val="1C1B19"/>
                 </a:solidFill>
@@ -6431,8 +6436,8 @@
         </p:nvSpPr>
         <p:spPr>
           <a:xfrm>
-            <a:off x="1371600" y="2926080"/>
-            <a:ext cx="9144000" cy="3200400"/>
+            <a:off x="731520" y="2926080"/>
+            <a:ext cx="10515600" cy="3200400"/>
           </a:xfrm>
           <a:prstGeom prst="rect">
             <a:avLst/>
@@ -6440,7 +6445,7 @@
           <a:noFill/>
         </p:spPr>
         <p:txBody>
-          <a:bodyPr wrap="none" anchor="t">
+          <a:bodyPr wrap="square" anchor="t">
             <a:spAutoFit/>
           </a:bodyPr>
           <a:lstStyle/>
@@ -6448,9 +6453,9 @@
           <a:p>
             <a:pPr>
               <a:spcAft>
-                <a:spcPts val="1600"/>
+                <a:spcPts val="1400"/>
               </a:spcAft>
-              <a:defRPr sz="2200">
+              <a:defRPr sz="2100">
                 <a:solidFill>
                   <a:srgbClr val="1C1B19"/>
                 </a:solidFill>
@@ -6464,9 +6469,9 @@
           <a:p>
             <a:pPr>
               <a:spcAft>
-                <a:spcPts val="1600"/>
+                <a:spcPts val="1400"/>
               </a:spcAft>
-              <a:defRPr sz="2200">
+              <a:defRPr sz="2100">
                 <a:solidFill>
                   <a:srgbClr val="1C1B19"/>
                 </a:solidFill>
@@ -6480,9 +6485,9 @@
           <a:p>
             <a:pPr>
               <a:spcAft>
-                <a:spcPts val="1600"/>
+                <a:spcPts val="1400"/>
               </a:spcAft>
-              <a:defRPr sz="2200">
+              <a:defRPr sz="2100">
                 <a:solidFill>
                   <a:srgbClr val="1C1B19"/>
                 </a:solidFill>
@@ -6654,8 +6659,8 @@
         </p:nvSpPr>
         <p:spPr>
           <a:xfrm>
-            <a:off x="1371600" y="2926080"/>
-            <a:ext cx="9144000" cy="3200400"/>
+            <a:off x="731520" y="2926080"/>
+            <a:ext cx="10515600" cy="3200400"/>
           </a:xfrm>
           <a:prstGeom prst="rect">
             <a:avLst/>
@@ -6663,7 +6668,7 @@
           <a:noFill/>
         </p:spPr>
         <p:txBody>
-          <a:bodyPr wrap="none" anchor="t">
+          <a:bodyPr wrap="square" anchor="t">
             <a:spAutoFit/>
           </a:bodyPr>
           <a:lstStyle/>
@@ -6671,9 +6676,9 @@
           <a:p>
             <a:pPr>
               <a:spcAft>
-                <a:spcPts val="1600"/>
+                <a:spcPts val="1400"/>
               </a:spcAft>
-              <a:defRPr sz="2200">
+              <a:defRPr sz="2100">
                 <a:solidFill>
                   <a:srgbClr val="1C1B19"/>
                 </a:solidFill>
@@ -6687,9 +6692,9 @@
           <a:p>
             <a:pPr>
               <a:spcAft>
-                <a:spcPts val="1600"/>
+                <a:spcPts val="1400"/>
               </a:spcAft>
-              <a:defRPr sz="2200">
+              <a:defRPr sz="2100">
                 <a:solidFill>
                   <a:srgbClr val="1C1B19"/>
                 </a:solidFill>
@@ -6703,9 +6708,9 @@
           <a:p>
             <a:pPr>
               <a:spcAft>
-                <a:spcPts val="1600"/>
+                <a:spcPts val="1400"/>
               </a:spcAft>
-              <a:defRPr sz="2200">
+              <a:defRPr sz="2100">
                 <a:solidFill>
                   <a:srgbClr val="1C1B19"/>
                 </a:solidFill>
@@ -6877,8 +6882,8 @@
         </p:nvSpPr>
         <p:spPr>
           <a:xfrm>
-            <a:off x="1371600" y="2926080"/>
-            <a:ext cx="9144000" cy="3200400"/>
+            <a:off x="731520" y="2926080"/>
+            <a:ext cx="10515600" cy="3200400"/>
           </a:xfrm>
           <a:prstGeom prst="rect">
             <a:avLst/>
@@ -6886,7 +6891,7 @@
           <a:noFill/>
         </p:spPr>
         <p:txBody>
-          <a:bodyPr wrap="none" anchor="t">
+          <a:bodyPr wrap="square" anchor="t">
             <a:spAutoFit/>
           </a:bodyPr>
           <a:lstStyle/>
@@ -6894,9 +6899,9 @@
           <a:p>
             <a:pPr>
               <a:spcAft>
-                <a:spcPts val="1600"/>
+                <a:spcPts val="1400"/>
               </a:spcAft>
-              <a:defRPr sz="2200">
+              <a:defRPr sz="2100">
                 <a:solidFill>
                   <a:srgbClr val="1C1B19"/>
                 </a:solidFill>
@@ -6910,9 +6915,9 @@
           <a:p>
             <a:pPr>
               <a:spcAft>
-                <a:spcPts val="1600"/>
+                <a:spcPts val="1400"/>
               </a:spcAft>
-              <a:defRPr sz="2200">
+              <a:defRPr sz="2100">
                 <a:solidFill>
                   <a:srgbClr val="1C1B19"/>
                 </a:solidFill>
@@ -6926,9 +6931,9 @@
           <a:p>
             <a:pPr>
               <a:spcAft>
-                <a:spcPts val="1600"/>
+                <a:spcPts val="1400"/>
               </a:spcAft>
-              <a:defRPr sz="2200">
+              <a:defRPr sz="2100">
                 <a:solidFill>
                   <a:srgbClr val="1C1B19"/>
                 </a:solidFill>
@@ -7103,7 +7108,7 @@
               </a:defRPr>
             </a:pPr>
             <a:r>
-              <a:t>✔ BaaSやEmbedded Financeにより、銀行の境界線が曖昧になっている。</a:t>
+              <a:t>✔ 外部サービスとの金融融合により、銀行の境界線が曖昧になっている。</a:t>
             </a:r>
           </a:p>
           <a:p>
@@ -7282,8 +7287,8 @@
         </p:nvSpPr>
         <p:spPr>
           <a:xfrm>
-            <a:off x="1371600" y="2926080"/>
-            <a:ext cx="9144000" cy="3200400"/>
+            <a:off x="731520" y="2926080"/>
+            <a:ext cx="10515600" cy="3200400"/>
           </a:xfrm>
           <a:prstGeom prst="rect">
             <a:avLst/>
@@ -7291,7 +7296,7 @@
           <a:noFill/>
         </p:spPr>
         <p:txBody>
-          <a:bodyPr wrap="none" anchor="t">
+          <a:bodyPr wrap="square" anchor="t">
             <a:spAutoFit/>
           </a:bodyPr>
           <a:lstStyle/>
@@ -7299,9 +7304,9 @@
           <a:p>
             <a:pPr>
               <a:spcAft>
-                <a:spcPts val="1600"/>
+                <a:spcPts val="1400"/>
               </a:spcAft>
-              <a:defRPr sz="2200">
+              <a:defRPr sz="2100">
                 <a:solidFill>
                   <a:srgbClr val="1C1B19"/>
                 </a:solidFill>
@@ -7315,9 +7320,9 @@
           <a:p>
             <a:pPr>
               <a:spcAft>
-                <a:spcPts val="1600"/>
+                <a:spcPts val="1400"/>
               </a:spcAft>
-              <a:defRPr sz="2200">
+              <a:defRPr sz="2100">
                 <a:solidFill>
                   <a:srgbClr val="1C1B19"/>
                 </a:solidFill>
@@ -7331,9 +7336,9 @@
           <a:p>
             <a:pPr>
               <a:spcAft>
-                <a:spcPts val="1600"/>
+                <a:spcPts val="1400"/>
               </a:spcAft>
-              <a:defRPr sz="2200">
+              <a:defRPr sz="2100">
                 <a:solidFill>
                   <a:srgbClr val="1C1B19"/>
                 </a:solidFill>
@@ -7505,8 +7510,8 @@
         </p:nvSpPr>
         <p:spPr>
           <a:xfrm>
-            <a:off x="1371600" y="2926080"/>
-            <a:ext cx="9144000" cy="3200400"/>
+            <a:off x="731520" y="2926080"/>
+            <a:ext cx="10515600" cy="3200400"/>
           </a:xfrm>
           <a:prstGeom prst="rect">
             <a:avLst/>
@@ -7514,7 +7519,7 @@
           <a:noFill/>
         </p:spPr>
         <p:txBody>
-          <a:bodyPr wrap="none" anchor="t">
+          <a:bodyPr wrap="square" anchor="t">
             <a:spAutoFit/>
           </a:bodyPr>
           <a:lstStyle/>
@@ -7522,9 +7527,9 @@
           <a:p>
             <a:pPr>
               <a:spcAft>
-                <a:spcPts val="1600"/>
+                <a:spcPts val="1400"/>
               </a:spcAft>
-              <a:defRPr sz="2200">
+              <a:defRPr sz="2100">
                 <a:solidFill>
                   <a:srgbClr val="1C1B19"/>
                 </a:solidFill>
@@ -7532,15 +7537,15 @@
               </a:defRPr>
             </a:pPr>
             <a:r>
-              <a:t>• Section 01: 1. 銀行の歴史（合併・再編）</a:t>
+              <a:t>• Section 01: 銀行の歴史（合併・再編）</a:t>
             </a:r>
           </a:p>
           <a:p>
             <a:pPr>
               <a:spcAft>
-                <a:spcPts val="1600"/>
+                <a:spcPts val="1400"/>
               </a:spcAft>
-              <a:defRPr sz="2200">
+              <a:defRPr sz="2100">
                 <a:solidFill>
                   <a:srgbClr val="1C1B19"/>
                 </a:solidFill>
@@ -7548,15 +7553,15 @@
               </a:defRPr>
             </a:pPr>
             <a:r>
-              <a:t>• Section 02: 2. 銀行の新たなビジネスモデル</a:t>
+              <a:t>• Section 02: 銀行の新たなビジネスモデル</a:t>
             </a:r>
           </a:p>
           <a:p>
             <a:pPr>
               <a:spcAft>
-                <a:spcPts val="1600"/>
+                <a:spcPts val="1400"/>
               </a:spcAft>
-              <a:defRPr sz="2200">
+              <a:defRPr sz="2100">
                 <a:solidFill>
                   <a:srgbClr val="1C1B19"/>
                 </a:solidFill>
@@ -7564,15 +7569,15 @@
               </a:defRPr>
             </a:pPr>
             <a:r>
-              <a:t>• Section 03: 3. 銀行業界の現状</a:t>
+              <a:t>• Section 03: 銀行業界の現状</a:t>
             </a:r>
           </a:p>
           <a:p>
             <a:pPr>
               <a:spcAft>
-                <a:spcPts val="1600"/>
+                <a:spcPts val="1400"/>
               </a:spcAft>
-              <a:defRPr sz="2200">
+              <a:defRPr sz="2100">
                 <a:solidFill>
                   <a:srgbClr val="1C1B19"/>
                 </a:solidFill>
@@ -7580,15 +7585,15 @@
               </a:defRPr>
             </a:pPr>
             <a:r>
-              <a:t>• Section 04: 4. 競合・新たな脅威</a:t>
+              <a:t>• Section 04: 競合・新たな脅威</a:t>
             </a:r>
           </a:p>
           <a:p>
             <a:pPr>
               <a:spcAft>
-                <a:spcPts val="1600"/>
+                <a:spcPts val="1400"/>
               </a:spcAft>
-              <a:defRPr sz="2200">
+              <a:defRPr sz="2100">
                 <a:solidFill>
                   <a:srgbClr val="1C1B19"/>
                 </a:solidFill>
@@ -7596,7 +7601,7 @@
               </a:defRPr>
             </a:pPr>
             <a:r>
-              <a:t>• Section 05: 5. 銀行の将来・今後の展望</a:t>
+              <a:t>• Section 05: 銀行の将来・今後の展望</a:t>
             </a:r>
           </a:p>
         </p:txBody>
@@ -8730,8 +8735,8 @@
         </p:nvSpPr>
         <p:spPr>
           <a:xfrm>
-            <a:off x="1371600" y="2926080"/>
-            <a:ext cx="9144000" cy="3200400"/>
+            <a:off x="731520" y="2926080"/>
+            <a:ext cx="10515600" cy="3200400"/>
           </a:xfrm>
           <a:prstGeom prst="rect">
             <a:avLst/>
@@ -8739,7 +8744,7 @@
           <a:noFill/>
         </p:spPr>
         <p:txBody>
-          <a:bodyPr wrap="none" anchor="t">
+          <a:bodyPr wrap="square" anchor="t">
             <a:spAutoFit/>
           </a:bodyPr>
           <a:lstStyle/>
@@ -8747,9 +8752,9 @@
           <a:p>
             <a:pPr>
               <a:spcAft>
-                <a:spcPts val="1600"/>
+                <a:spcPts val="1400"/>
               </a:spcAft>
-              <a:defRPr sz="2200">
+              <a:defRPr sz="2100">
                 <a:solidFill>
                   <a:srgbClr val="1C1B19"/>
                 </a:solidFill>
@@ -8763,9 +8768,9 @@
           <a:p>
             <a:pPr>
               <a:spcAft>
-                <a:spcPts val="1600"/>
+                <a:spcPts val="1400"/>
               </a:spcAft>
-              <a:defRPr sz="2200">
+              <a:defRPr sz="2100">
                 <a:solidFill>
                   <a:srgbClr val="1C1B19"/>
                 </a:solidFill>
@@ -8779,9 +8784,9 @@
           <a:p>
             <a:pPr>
               <a:spcAft>
-                <a:spcPts val="1600"/>
+                <a:spcPts val="1400"/>
               </a:spcAft>
-              <a:defRPr sz="2200">
+              <a:defRPr sz="2100">
                 <a:solidFill>
                   <a:srgbClr val="1C1B19"/>
                 </a:solidFill>
@@ -8953,8 +8958,8 @@
         </p:nvSpPr>
         <p:spPr>
           <a:xfrm>
-            <a:off x="1371600" y="2926080"/>
-            <a:ext cx="9144000" cy="3200400"/>
+            <a:off x="731520" y="2926080"/>
+            <a:ext cx="10515600" cy="3200400"/>
           </a:xfrm>
           <a:prstGeom prst="rect">
             <a:avLst/>
@@ -8962,7 +8967,7 @@
           <a:noFill/>
         </p:spPr>
         <p:txBody>
-          <a:bodyPr wrap="none" anchor="t">
+          <a:bodyPr wrap="square" anchor="t">
             <a:spAutoFit/>
           </a:bodyPr>
           <a:lstStyle/>
@@ -8970,9 +8975,9 @@
           <a:p>
             <a:pPr>
               <a:spcAft>
-                <a:spcPts val="1600"/>
+                <a:spcPts val="1400"/>
               </a:spcAft>
-              <a:defRPr sz="2200">
+              <a:defRPr sz="2100">
                 <a:solidFill>
                   <a:srgbClr val="1C1B19"/>
                 </a:solidFill>
@@ -8986,9 +8991,9 @@
           <a:p>
             <a:pPr>
               <a:spcAft>
-                <a:spcPts val="1600"/>
+                <a:spcPts val="1400"/>
               </a:spcAft>
-              <a:defRPr sz="2200">
+              <a:defRPr sz="2100">
                 <a:solidFill>
                   <a:srgbClr val="1C1B19"/>
                 </a:solidFill>
@@ -9002,9 +9007,9 @@
           <a:p>
             <a:pPr>
               <a:spcAft>
-                <a:spcPts val="1600"/>
+                <a:spcPts val="1400"/>
               </a:spcAft>
-              <a:defRPr sz="2200">
+              <a:defRPr sz="2100">
                 <a:solidFill>
                   <a:srgbClr val="1C1B19"/>
                 </a:solidFill>

</xml_diff>

<commit_message>
Fix SUMMARY slide text overflow by enabling word wrap and adjusting layout (s)
</commit_message>
<xml_diff>
--- a/design-strategy/bank_strategy_presentation.pptx
+++ b/design-strategy/bank_strategy_presentation.pptx
@@ -3409,7 +3409,7 @@
         <p:spPr>
           <a:xfrm>
             <a:off x="731520" y="2926080"/>
-            <a:ext cx="10515600" cy="3200400"/>
+            <a:ext cx="10698480" cy="3200400"/>
           </a:xfrm>
           <a:prstGeom prst="rect">
             <a:avLst/>
@@ -4005,7 +4005,7 @@
         <p:spPr>
           <a:xfrm>
             <a:off x="731520" y="2926080"/>
-            <a:ext cx="10515600" cy="3200400"/>
+            <a:ext cx="10698480" cy="3200400"/>
           </a:xfrm>
           <a:prstGeom prst="rect">
             <a:avLst/>
@@ -5271,7 +5271,7 @@
         <p:spPr>
           <a:xfrm>
             <a:off x="731520" y="2926080"/>
-            <a:ext cx="10515600" cy="3200400"/>
+            <a:ext cx="10698480" cy="3200400"/>
           </a:xfrm>
           <a:prstGeom prst="rect">
             <a:avLst/>
@@ -5629,7 +5629,7 @@
         <p:spPr>
           <a:xfrm>
             <a:off x="731520" y="2926080"/>
-            <a:ext cx="10515600" cy="3200400"/>
+            <a:ext cx="10698480" cy="3200400"/>
           </a:xfrm>
           <a:prstGeom prst="rect">
             <a:avLst/>
@@ -5852,7 +5852,7 @@
         <p:spPr>
           <a:xfrm>
             <a:off x="731520" y="2926080"/>
-            <a:ext cx="10515600" cy="3200400"/>
+            <a:ext cx="10698480" cy="3200400"/>
           </a:xfrm>
           <a:prstGeom prst="rect">
             <a:avLst/>
@@ -6079,7 +6079,7 @@
         <p:spPr>
           <a:xfrm>
             <a:off x="731520" y="2926080"/>
-            <a:ext cx="10515600" cy="3200400"/>
+            <a:ext cx="10698480" cy="3200400"/>
           </a:xfrm>
           <a:prstGeom prst="rect">
             <a:avLst/>
@@ -6437,7 +6437,7 @@
         <p:spPr>
           <a:xfrm>
             <a:off x="731520" y="2926080"/>
-            <a:ext cx="10515600" cy="3200400"/>
+            <a:ext cx="10698480" cy="3200400"/>
           </a:xfrm>
           <a:prstGeom prst="rect">
             <a:avLst/>
@@ -6660,7 +6660,7 @@
         <p:spPr>
           <a:xfrm>
             <a:off x="731520" y="2926080"/>
-            <a:ext cx="10515600" cy="3200400"/>
+            <a:ext cx="10698480" cy="3200400"/>
           </a:xfrm>
           <a:prstGeom prst="rect">
             <a:avLst/>
@@ -6883,7 +6883,7 @@
         <p:spPr>
           <a:xfrm>
             <a:off x="731520" y="2926080"/>
-            <a:ext cx="10515600" cy="3200400"/>
+            <a:ext cx="10698480" cy="3200400"/>
           </a:xfrm>
           <a:prstGeom prst="rect">
             <a:avLst/>
@@ -7052,8 +7052,8 @@
         </p:nvSpPr>
         <p:spPr>
           <a:xfrm>
-            <a:off x="1371600" y="2286000"/>
-            <a:ext cx="9144000" cy="3657600"/>
+            <a:off x="731520" y="2286000"/>
+            <a:ext cx="10698480" cy="3657600"/>
           </a:xfrm>
           <a:prstGeom prst="rect">
             <a:avLst/>
@@ -7061,7 +7061,7 @@
           <a:noFill/>
         </p:spPr>
         <p:txBody>
-          <a:bodyPr wrap="none">
+          <a:bodyPr wrap="square">
             <a:spAutoFit/>
           </a:bodyPr>
           <a:lstStyle/>
@@ -7069,9 +7069,9 @@
           <a:p>
             <a:pPr>
               <a:spcAft>
-                <a:spcPts val="2400"/>
+                <a:spcPts val="2000"/>
               </a:spcAft>
-              <a:defRPr sz="2800">
+              <a:defRPr sz="2200">
                 <a:solidFill>
                   <a:srgbClr val="1C1B19"/>
                 </a:solidFill>
@@ -7084,9 +7084,9 @@
           <a:p>
             <a:pPr>
               <a:spcAft>
-                <a:spcPts val="2400"/>
+                <a:spcPts val="2000"/>
               </a:spcAft>
-              <a:defRPr sz="2800">
+              <a:defRPr sz="2200">
                 <a:solidFill>
                   <a:srgbClr val="1C1B19"/>
                 </a:solidFill>
@@ -7099,9 +7099,9 @@
           <a:p>
             <a:pPr>
               <a:spcAft>
-                <a:spcPts val="2400"/>
+                <a:spcPts val="2000"/>
               </a:spcAft>
-              <a:defRPr sz="2800">
+              <a:defRPr sz="2200">
                 <a:solidFill>
                   <a:srgbClr val="1C1B19"/>
                 </a:solidFill>
@@ -7114,9 +7114,9 @@
           <a:p>
             <a:pPr>
               <a:spcAft>
-                <a:spcPts val="2400"/>
+                <a:spcPts val="2000"/>
               </a:spcAft>
-              <a:defRPr sz="2800">
+              <a:defRPr sz="2200">
                 <a:solidFill>
                   <a:srgbClr val="1C1B19"/>
                 </a:solidFill>
@@ -7288,7 +7288,7 @@
         <p:spPr>
           <a:xfrm>
             <a:off x="731520" y="2926080"/>
-            <a:ext cx="10515600" cy="3200400"/>
+            <a:ext cx="10698480" cy="3200400"/>
           </a:xfrm>
           <a:prstGeom prst="rect">
             <a:avLst/>
@@ -7511,7 +7511,7 @@
         <p:spPr>
           <a:xfrm>
             <a:off x="731520" y="2926080"/>
-            <a:ext cx="10515600" cy="3200400"/>
+            <a:ext cx="10698480" cy="3200400"/>
           </a:xfrm>
           <a:prstGeom prst="rect">
             <a:avLst/>
@@ -8736,7 +8736,7 @@
         <p:spPr>
           <a:xfrm>
             <a:off x="731520" y="2926080"/>
-            <a:ext cx="10515600" cy="3200400"/>
+            <a:ext cx="10698480" cy="3200400"/>
           </a:xfrm>
           <a:prstGeom prst="rect">
             <a:avLst/>
@@ -8959,7 +8959,7 @@
         <p:spPr>
           <a:xfrm>
             <a:off x="731520" y="2926080"/>
-            <a:ext cx="10515600" cy="3200400"/>
+            <a:ext cx="10698480" cy="3200400"/>
           </a:xfrm>
           <a:prstGeom prst="rect">
             <a:avLst/>

</xml_diff>

<commit_message>
Optimize font sizes (23pt/25pt) for better visibility without overflow (s)
</commit_message>
<xml_diff>
--- a/design-strategy/bank_strategy_presentation.pptx
+++ b/design-strategy/bank_strategy_presentation.pptx
@@ -3425,9 +3425,9 @@
           <a:p>
             <a:pPr>
               <a:spcAft>
-                <a:spcPts val="1400"/>
+                <a:spcPts val="1600"/>
               </a:spcAft>
-              <a:defRPr sz="2100">
+              <a:defRPr sz="2300">
                 <a:solidFill>
                   <a:srgbClr val="1C1B19"/>
                 </a:solidFill>
@@ -3441,9 +3441,9 @@
           <a:p>
             <a:pPr>
               <a:spcAft>
-                <a:spcPts val="1400"/>
+                <a:spcPts val="1600"/>
               </a:spcAft>
-              <a:defRPr sz="2100">
+              <a:defRPr sz="2300">
                 <a:solidFill>
                   <a:srgbClr val="1C1B19"/>
                 </a:solidFill>
@@ -3457,9 +3457,9 @@
           <a:p>
             <a:pPr>
               <a:spcAft>
-                <a:spcPts val="1400"/>
+                <a:spcPts val="1600"/>
               </a:spcAft>
-              <a:defRPr sz="2100">
+              <a:defRPr sz="2300">
                 <a:solidFill>
                   <a:srgbClr val="1C1B19"/>
                 </a:solidFill>
@@ -4021,9 +4021,9 @@
           <a:p>
             <a:pPr>
               <a:spcAft>
-                <a:spcPts val="1400"/>
+                <a:spcPts val="1600"/>
               </a:spcAft>
-              <a:defRPr sz="2100">
+              <a:defRPr sz="2300">
                 <a:solidFill>
                   <a:srgbClr val="1C1B19"/>
                 </a:solidFill>
@@ -4037,9 +4037,9 @@
           <a:p>
             <a:pPr>
               <a:spcAft>
-                <a:spcPts val="1400"/>
+                <a:spcPts val="1600"/>
               </a:spcAft>
-              <a:defRPr sz="2100">
+              <a:defRPr sz="2300">
                 <a:solidFill>
                   <a:srgbClr val="1C1B19"/>
                 </a:solidFill>
@@ -4053,9 +4053,9 @@
           <a:p>
             <a:pPr>
               <a:spcAft>
-                <a:spcPts val="1400"/>
+                <a:spcPts val="1600"/>
               </a:spcAft>
-              <a:defRPr sz="2100">
+              <a:defRPr sz="2300">
                 <a:solidFill>
                   <a:srgbClr val="1C1B19"/>
                 </a:solidFill>
@@ -5287,9 +5287,9 @@
           <a:p>
             <a:pPr>
               <a:spcAft>
-                <a:spcPts val="1400"/>
+                <a:spcPts val="1600"/>
               </a:spcAft>
-              <a:defRPr sz="2100">
+              <a:defRPr sz="2300">
                 <a:solidFill>
                   <a:srgbClr val="1C1B19"/>
                 </a:solidFill>
@@ -5303,9 +5303,9 @@
           <a:p>
             <a:pPr>
               <a:spcAft>
-                <a:spcPts val="1400"/>
+                <a:spcPts val="1600"/>
               </a:spcAft>
-              <a:defRPr sz="2100">
+              <a:defRPr sz="2300">
                 <a:solidFill>
                   <a:srgbClr val="1C1B19"/>
                 </a:solidFill>
@@ -5319,9 +5319,9 @@
           <a:p>
             <a:pPr>
               <a:spcAft>
-                <a:spcPts val="1400"/>
+                <a:spcPts val="1600"/>
               </a:spcAft>
-              <a:defRPr sz="2100">
+              <a:defRPr sz="2300">
                 <a:solidFill>
                   <a:srgbClr val="1C1B19"/>
                 </a:solidFill>
@@ -5645,9 +5645,9 @@
           <a:p>
             <a:pPr>
               <a:spcAft>
-                <a:spcPts val="1400"/>
+                <a:spcPts val="1600"/>
               </a:spcAft>
-              <a:defRPr sz="2100">
+              <a:defRPr sz="2300">
                 <a:solidFill>
                   <a:srgbClr val="1C1B19"/>
                 </a:solidFill>
@@ -5661,9 +5661,9 @@
           <a:p>
             <a:pPr>
               <a:spcAft>
-                <a:spcPts val="1400"/>
+                <a:spcPts val="1600"/>
               </a:spcAft>
-              <a:defRPr sz="2100">
+              <a:defRPr sz="2300">
                 <a:solidFill>
                   <a:srgbClr val="1C1B19"/>
                 </a:solidFill>
@@ -5677,9 +5677,9 @@
           <a:p>
             <a:pPr>
               <a:spcAft>
-                <a:spcPts val="1400"/>
+                <a:spcPts val="1600"/>
               </a:spcAft>
-              <a:defRPr sz="2100">
+              <a:defRPr sz="2300">
                 <a:solidFill>
                   <a:srgbClr val="1C1B19"/>
                 </a:solidFill>
@@ -5868,9 +5868,9 @@
           <a:p>
             <a:pPr>
               <a:spcAft>
-                <a:spcPts val="1400"/>
+                <a:spcPts val="1600"/>
               </a:spcAft>
-              <a:defRPr sz="2100">
+              <a:defRPr sz="2300">
                 <a:solidFill>
                   <a:srgbClr val="1C1B19"/>
                 </a:solidFill>
@@ -5884,9 +5884,9 @@
           <a:p>
             <a:pPr>
               <a:spcAft>
-                <a:spcPts val="1400"/>
+                <a:spcPts val="1600"/>
               </a:spcAft>
-              <a:defRPr sz="2100">
+              <a:defRPr sz="2300">
                 <a:solidFill>
                   <a:srgbClr val="1C1B19"/>
                 </a:solidFill>
@@ -5900,9 +5900,9 @@
           <a:p>
             <a:pPr>
               <a:spcAft>
-                <a:spcPts val="1400"/>
+                <a:spcPts val="1600"/>
               </a:spcAft>
-              <a:defRPr sz="2100">
+              <a:defRPr sz="2300">
                 <a:solidFill>
                   <a:srgbClr val="1C1B19"/>
                 </a:solidFill>
@@ -6095,9 +6095,9 @@
           <a:p>
             <a:pPr>
               <a:spcAft>
-                <a:spcPts val="1400"/>
+                <a:spcPts val="1600"/>
               </a:spcAft>
-              <a:defRPr sz="2100">
+              <a:defRPr sz="2300">
                 <a:solidFill>
                   <a:srgbClr val="1C1B19"/>
                 </a:solidFill>
@@ -6111,9 +6111,9 @@
           <a:p>
             <a:pPr>
               <a:spcAft>
-                <a:spcPts val="1400"/>
+                <a:spcPts val="1600"/>
               </a:spcAft>
-              <a:defRPr sz="2100">
+              <a:defRPr sz="2300">
                 <a:solidFill>
                   <a:srgbClr val="1C1B19"/>
                 </a:solidFill>
@@ -6127,9 +6127,9 @@
           <a:p>
             <a:pPr>
               <a:spcAft>
-                <a:spcPts val="1400"/>
+                <a:spcPts val="1600"/>
               </a:spcAft>
-              <a:defRPr sz="2100">
+              <a:defRPr sz="2300">
                 <a:solidFill>
                   <a:srgbClr val="1C1B19"/>
                 </a:solidFill>
@@ -6453,9 +6453,9 @@
           <a:p>
             <a:pPr>
               <a:spcAft>
-                <a:spcPts val="1400"/>
+                <a:spcPts val="1600"/>
               </a:spcAft>
-              <a:defRPr sz="2100">
+              <a:defRPr sz="2300">
                 <a:solidFill>
                   <a:srgbClr val="1C1B19"/>
                 </a:solidFill>
@@ -6469,9 +6469,9 @@
           <a:p>
             <a:pPr>
               <a:spcAft>
-                <a:spcPts val="1400"/>
+                <a:spcPts val="1600"/>
               </a:spcAft>
-              <a:defRPr sz="2100">
+              <a:defRPr sz="2300">
                 <a:solidFill>
                   <a:srgbClr val="1C1B19"/>
                 </a:solidFill>
@@ -6485,9 +6485,9 @@
           <a:p>
             <a:pPr>
               <a:spcAft>
-                <a:spcPts val="1400"/>
+                <a:spcPts val="1600"/>
               </a:spcAft>
-              <a:defRPr sz="2100">
+              <a:defRPr sz="2300">
                 <a:solidFill>
                   <a:srgbClr val="1C1B19"/>
                 </a:solidFill>
@@ -6676,9 +6676,9 @@
           <a:p>
             <a:pPr>
               <a:spcAft>
-                <a:spcPts val="1400"/>
+                <a:spcPts val="1600"/>
               </a:spcAft>
-              <a:defRPr sz="2100">
+              <a:defRPr sz="2300">
                 <a:solidFill>
                   <a:srgbClr val="1C1B19"/>
                 </a:solidFill>
@@ -6692,9 +6692,9 @@
           <a:p>
             <a:pPr>
               <a:spcAft>
-                <a:spcPts val="1400"/>
+                <a:spcPts val="1600"/>
               </a:spcAft>
-              <a:defRPr sz="2100">
+              <a:defRPr sz="2300">
                 <a:solidFill>
                   <a:srgbClr val="1C1B19"/>
                 </a:solidFill>
@@ -6708,9 +6708,9 @@
           <a:p>
             <a:pPr>
               <a:spcAft>
-                <a:spcPts val="1400"/>
+                <a:spcPts val="1600"/>
               </a:spcAft>
-              <a:defRPr sz="2100">
+              <a:defRPr sz="2300">
                 <a:solidFill>
                   <a:srgbClr val="1C1B19"/>
                 </a:solidFill>
@@ -6899,9 +6899,9 @@
           <a:p>
             <a:pPr>
               <a:spcAft>
-                <a:spcPts val="1400"/>
+                <a:spcPts val="1600"/>
               </a:spcAft>
-              <a:defRPr sz="2100">
+              <a:defRPr sz="2300">
                 <a:solidFill>
                   <a:srgbClr val="1C1B19"/>
                 </a:solidFill>
@@ -6915,9 +6915,9 @@
           <a:p>
             <a:pPr>
               <a:spcAft>
-                <a:spcPts val="1400"/>
+                <a:spcPts val="1600"/>
               </a:spcAft>
-              <a:defRPr sz="2100">
+              <a:defRPr sz="2300">
                 <a:solidFill>
                   <a:srgbClr val="1C1B19"/>
                 </a:solidFill>
@@ -6931,9 +6931,9 @@
           <a:p>
             <a:pPr>
               <a:spcAft>
-                <a:spcPts val="1400"/>
+                <a:spcPts val="1600"/>
               </a:spcAft>
-              <a:defRPr sz="2100">
+              <a:defRPr sz="2300">
                 <a:solidFill>
                   <a:srgbClr val="1C1B19"/>
                 </a:solidFill>
@@ -7069,9 +7069,9 @@
           <a:p>
             <a:pPr>
               <a:spcAft>
-                <a:spcPts val="2000"/>
+                <a:spcPts val="2200"/>
               </a:spcAft>
-              <a:defRPr sz="2200">
+              <a:defRPr sz="2500">
                 <a:solidFill>
                   <a:srgbClr val="1C1B19"/>
                 </a:solidFill>
@@ -7084,9 +7084,9 @@
           <a:p>
             <a:pPr>
               <a:spcAft>
-                <a:spcPts val="2000"/>
+                <a:spcPts val="2200"/>
               </a:spcAft>
-              <a:defRPr sz="2200">
+              <a:defRPr sz="2500">
                 <a:solidFill>
                   <a:srgbClr val="1C1B19"/>
                 </a:solidFill>
@@ -7099,9 +7099,9 @@
           <a:p>
             <a:pPr>
               <a:spcAft>
-                <a:spcPts val="2000"/>
+                <a:spcPts val="2200"/>
               </a:spcAft>
-              <a:defRPr sz="2200">
+              <a:defRPr sz="2500">
                 <a:solidFill>
                   <a:srgbClr val="1C1B19"/>
                 </a:solidFill>
@@ -7114,9 +7114,9 @@
           <a:p>
             <a:pPr>
               <a:spcAft>
-                <a:spcPts val="2000"/>
+                <a:spcPts val="2200"/>
               </a:spcAft>
-              <a:defRPr sz="2200">
+              <a:defRPr sz="2500">
                 <a:solidFill>
                   <a:srgbClr val="1C1B19"/>
                 </a:solidFill>
@@ -7304,9 +7304,9 @@
           <a:p>
             <a:pPr>
               <a:spcAft>
-                <a:spcPts val="1400"/>
+                <a:spcPts val="1600"/>
               </a:spcAft>
-              <a:defRPr sz="2100">
+              <a:defRPr sz="2300">
                 <a:solidFill>
                   <a:srgbClr val="1C1B19"/>
                 </a:solidFill>
@@ -7320,9 +7320,9 @@
           <a:p>
             <a:pPr>
               <a:spcAft>
-                <a:spcPts val="1400"/>
+                <a:spcPts val="1600"/>
               </a:spcAft>
-              <a:defRPr sz="2100">
+              <a:defRPr sz="2300">
                 <a:solidFill>
                   <a:srgbClr val="1C1B19"/>
                 </a:solidFill>
@@ -7336,9 +7336,9 @@
           <a:p>
             <a:pPr>
               <a:spcAft>
-                <a:spcPts val="1400"/>
+                <a:spcPts val="1600"/>
               </a:spcAft>
-              <a:defRPr sz="2100">
+              <a:defRPr sz="2300">
                 <a:solidFill>
                   <a:srgbClr val="1C1B19"/>
                 </a:solidFill>
@@ -7527,9 +7527,9 @@
           <a:p>
             <a:pPr>
               <a:spcAft>
-                <a:spcPts val="1400"/>
+                <a:spcPts val="1600"/>
               </a:spcAft>
-              <a:defRPr sz="2100">
+              <a:defRPr sz="2300">
                 <a:solidFill>
                   <a:srgbClr val="1C1B19"/>
                 </a:solidFill>
@@ -7543,9 +7543,9 @@
           <a:p>
             <a:pPr>
               <a:spcAft>
-                <a:spcPts val="1400"/>
+                <a:spcPts val="1600"/>
               </a:spcAft>
-              <a:defRPr sz="2100">
+              <a:defRPr sz="2300">
                 <a:solidFill>
                   <a:srgbClr val="1C1B19"/>
                 </a:solidFill>
@@ -7559,9 +7559,9 @@
           <a:p>
             <a:pPr>
               <a:spcAft>
-                <a:spcPts val="1400"/>
+                <a:spcPts val="1600"/>
               </a:spcAft>
-              <a:defRPr sz="2100">
+              <a:defRPr sz="2300">
                 <a:solidFill>
                   <a:srgbClr val="1C1B19"/>
                 </a:solidFill>
@@ -7575,9 +7575,9 @@
           <a:p>
             <a:pPr>
               <a:spcAft>
-                <a:spcPts val="1400"/>
+                <a:spcPts val="1600"/>
               </a:spcAft>
-              <a:defRPr sz="2100">
+              <a:defRPr sz="2300">
                 <a:solidFill>
                   <a:srgbClr val="1C1B19"/>
                 </a:solidFill>
@@ -7591,9 +7591,9 @@
           <a:p>
             <a:pPr>
               <a:spcAft>
-                <a:spcPts val="1400"/>
+                <a:spcPts val="1600"/>
               </a:spcAft>
-              <a:defRPr sz="2100">
+              <a:defRPr sz="2300">
                 <a:solidFill>
                   <a:srgbClr val="1C1B19"/>
                 </a:solidFill>
@@ -8752,9 +8752,9 @@
           <a:p>
             <a:pPr>
               <a:spcAft>
-                <a:spcPts val="1400"/>
+                <a:spcPts val="1600"/>
               </a:spcAft>
-              <a:defRPr sz="2100">
+              <a:defRPr sz="2300">
                 <a:solidFill>
                   <a:srgbClr val="1C1B19"/>
                 </a:solidFill>
@@ -8768,9 +8768,9 @@
           <a:p>
             <a:pPr>
               <a:spcAft>
-                <a:spcPts val="1400"/>
+                <a:spcPts val="1600"/>
               </a:spcAft>
-              <a:defRPr sz="2100">
+              <a:defRPr sz="2300">
                 <a:solidFill>
                   <a:srgbClr val="1C1B19"/>
                 </a:solidFill>
@@ -8784,9 +8784,9 @@
           <a:p>
             <a:pPr>
               <a:spcAft>
-                <a:spcPts val="1400"/>
+                <a:spcPts val="1600"/>
               </a:spcAft>
-              <a:defRPr sz="2100">
+              <a:defRPr sz="2300">
                 <a:solidFill>
                   <a:srgbClr val="1C1B19"/>
                 </a:solidFill>
@@ -8975,9 +8975,9 @@
           <a:p>
             <a:pPr>
               <a:spcAft>
-                <a:spcPts val="1400"/>
+                <a:spcPts val="1600"/>
               </a:spcAft>
-              <a:defRPr sz="2100">
+              <a:defRPr sz="2300">
                 <a:solidFill>
                   <a:srgbClr val="1C1B19"/>
                 </a:solidFill>
@@ -8991,9 +8991,9 @@
           <a:p>
             <a:pPr>
               <a:spcAft>
-                <a:spcPts val="1400"/>
+                <a:spcPts val="1600"/>
               </a:spcAft>
-              <a:defRPr sz="2100">
+              <a:defRPr sz="2300">
                 <a:solidFill>
                   <a:srgbClr val="1C1B19"/>
                 </a:solidFill>
@@ -9007,9 +9007,9 @@
           <a:p>
             <a:pPr>
               <a:spcAft>
-                <a:spcPts val="1400"/>
+                <a:spcPts val="1600"/>
               </a:spcAft>
-              <a:defRPr sz="2100">
+              <a:defRPr sz="2300">
                 <a:solidFill>
                   <a:srgbClr val="1C1B19"/>
                 </a:solidFill>

</xml_diff>

<commit_message>
Further widen text boxes to prevent punctuation wrapping (s)
</commit_message>
<xml_diff>
--- a/design-strategy/bank_strategy_presentation.pptx
+++ b/design-strategy/bank_strategy_presentation.pptx
@@ -3408,8 +3408,8 @@
         </p:nvSpPr>
         <p:spPr>
           <a:xfrm>
-            <a:off x="731520" y="2926080"/>
-            <a:ext cx="10698480" cy="3200400"/>
+            <a:off x="548640" y="2926080"/>
+            <a:ext cx="11155680" cy="3200400"/>
           </a:xfrm>
           <a:prstGeom prst="rect">
             <a:avLst/>
@@ -4004,8 +4004,8 @@
         </p:nvSpPr>
         <p:spPr>
           <a:xfrm>
-            <a:off x="731520" y="2926080"/>
-            <a:ext cx="10698480" cy="3200400"/>
+            <a:off x="548640" y="2926080"/>
+            <a:ext cx="11155680" cy="3200400"/>
           </a:xfrm>
           <a:prstGeom prst="rect">
             <a:avLst/>
@@ -5270,8 +5270,8 @@
         </p:nvSpPr>
         <p:spPr>
           <a:xfrm>
-            <a:off x="731520" y="2926080"/>
-            <a:ext cx="10698480" cy="3200400"/>
+            <a:off x="548640" y="2926080"/>
+            <a:ext cx="11155680" cy="3200400"/>
           </a:xfrm>
           <a:prstGeom prst="rect">
             <a:avLst/>
@@ -5628,8 +5628,8 @@
         </p:nvSpPr>
         <p:spPr>
           <a:xfrm>
-            <a:off x="731520" y="2926080"/>
-            <a:ext cx="10698480" cy="3200400"/>
+            <a:off x="548640" y="2926080"/>
+            <a:ext cx="11155680" cy="3200400"/>
           </a:xfrm>
           <a:prstGeom prst="rect">
             <a:avLst/>
@@ -5851,8 +5851,8 @@
         </p:nvSpPr>
         <p:spPr>
           <a:xfrm>
-            <a:off x="731520" y="2926080"/>
-            <a:ext cx="10698480" cy="3200400"/>
+            <a:off x="548640" y="2926080"/>
+            <a:ext cx="11155680" cy="3200400"/>
           </a:xfrm>
           <a:prstGeom prst="rect">
             <a:avLst/>
@@ -6078,8 +6078,8 @@
         </p:nvSpPr>
         <p:spPr>
           <a:xfrm>
-            <a:off x="731520" y="2926080"/>
-            <a:ext cx="10698480" cy="3200400"/>
+            <a:off x="548640" y="2926080"/>
+            <a:ext cx="11155680" cy="3200400"/>
           </a:xfrm>
           <a:prstGeom prst="rect">
             <a:avLst/>
@@ -6436,8 +6436,8 @@
         </p:nvSpPr>
         <p:spPr>
           <a:xfrm>
-            <a:off x="731520" y="2926080"/>
-            <a:ext cx="10698480" cy="3200400"/>
+            <a:off x="548640" y="2926080"/>
+            <a:ext cx="11155680" cy="3200400"/>
           </a:xfrm>
           <a:prstGeom prst="rect">
             <a:avLst/>
@@ -6659,8 +6659,8 @@
         </p:nvSpPr>
         <p:spPr>
           <a:xfrm>
-            <a:off x="731520" y="2926080"/>
-            <a:ext cx="10698480" cy="3200400"/>
+            <a:off x="548640" y="2926080"/>
+            <a:ext cx="11155680" cy="3200400"/>
           </a:xfrm>
           <a:prstGeom prst="rect">
             <a:avLst/>
@@ -6882,8 +6882,8 @@
         </p:nvSpPr>
         <p:spPr>
           <a:xfrm>
-            <a:off x="731520" y="2926080"/>
-            <a:ext cx="10698480" cy="3200400"/>
+            <a:off x="548640" y="2926080"/>
+            <a:ext cx="11155680" cy="3200400"/>
           </a:xfrm>
           <a:prstGeom prst="rect">
             <a:avLst/>
@@ -7052,8 +7052,8 @@
         </p:nvSpPr>
         <p:spPr>
           <a:xfrm>
-            <a:off x="731520" y="2286000"/>
-            <a:ext cx="10698480" cy="3657600"/>
+            <a:off x="548640" y="2286000"/>
+            <a:ext cx="11155680" cy="3657600"/>
           </a:xfrm>
           <a:prstGeom prst="rect">
             <a:avLst/>
@@ -7287,8 +7287,8 @@
         </p:nvSpPr>
         <p:spPr>
           <a:xfrm>
-            <a:off x="731520" y="2926080"/>
-            <a:ext cx="10698480" cy="3200400"/>
+            <a:off x="548640" y="2926080"/>
+            <a:ext cx="11155680" cy="3200400"/>
           </a:xfrm>
           <a:prstGeom prst="rect">
             <a:avLst/>
@@ -7510,8 +7510,8 @@
         </p:nvSpPr>
         <p:spPr>
           <a:xfrm>
-            <a:off x="731520" y="2926080"/>
-            <a:ext cx="10698480" cy="3200400"/>
+            <a:off x="548640" y="2926080"/>
+            <a:ext cx="11155680" cy="3200400"/>
           </a:xfrm>
           <a:prstGeom prst="rect">
             <a:avLst/>
@@ -8735,8 +8735,8 @@
         </p:nvSpPr>
         <p:spPr>
           <a:xfrm>
-            <a:off x="731520" y="2926080"/>
-            <a:ext cx="10698480" cy="3200400"/>
+            <a:off x="548640" y="2926080"/>
+            <a:ext cx="11155680" cy="3200400"/>
           </a:xfrm>
           <a:prstGeom prst="rect">
             <a:avLst/>
@@ -8958,8 +8958,8 @@
         </p:nvSpPr>
         <p:spPr>
           <a:xfrm>
-            <a:off x="731520" y="2926080"/>
-            <a:ext cx="10698480" cy="3200400"/>
+            <a:off x="548640" y="2926080"/>
+            <a:ext cx="11155680" cy="3200400"/>
           </a:xfrm>
           <a:prstGeom prst="rect">
             <a:avLst/>

</xml_diff>

<commit_message>
Maximize text box width and fine-tune font size to fix punctuation wrap issues (s)
</commit_message>
<xml_diff>
--- a/design-strategy/bank_strategy_presentation.pptx
+++ b/design-strategy/bank_strategy_presentation.pptx
@@ -3408,8 +3408,8 @@
         </p:nvSpPr>
         <p:spPr>
           <a:xfrm>
-            <a:off x="548640" y="2926080"/>
-            <a:ext cx="11155680" cy="3200400"/>
+            <a:off x="365760" y="2926080"/>
+            <a:ext cx="11430000" cy="3200400"/>
           </a:xfrm>
           <a:prstGeom prst="rect">
             <a:avLst/>
@@ -4004,8 +4004,8 @@
         </p:nvSpPr>
         <p:spPr>
           <a:xfrm>
-            <a:off x="548640" y="2926080"/>
-            <a:ext cx="11155680" cy="3200400"/>
+            <a:off x="365760" y="2926080"/>
+            <a:ext cx="11430000" cy="3200400"/>
           </a:xfrm>
           <a:prstGeom prst="rect">
             <a:avLst/>
@@ -5270,8 +5270,8 @@
         </p:nvSpPr>
         <p:spPr>
           <a:xfrm>
-            <a:off x="548640" y="2926080"/>
-            <a:ext cx="11155680" cy="3200400"/>
+            <a:off x="365760" y="2926080"/>
+            <a:ext cx="11430000" cy="3200400"/>
           </a:xfrm>
           <a:prstGeom prst="rect">
             <a:avLst/>
@@ -5628,8 +5628,8 @@
         </p:nvSpPr>
         <p:spPr>
           <a:xfrm>
-            <a:off x="548640" y="2926080"/>
-            <a:ext cx="11155680" cy="3200400"/>
+            <a:off x="365760" y="2926080"/>
+            <a:ext cx="11430000" cy="3200400"/>
           </a:xfrm>
           <a:prstGeom prst="rect">
             <a:avLst/>
@@ -5851,8 +5851,8 @@
         </p:nvSpPr>
         <p:spPr>
           <a:xfrm>
-            <a:off x="548640" y="2926080"/>
-            <a:ext cx="11155680" cy="3200400"/>
+            <a:off x="365760" y="2926080"/>
+            <a:ext cx="11430000" cy="3200400"/>
           </a:xfrm>
           <a:prstGeom prst="rect">
             <a:avLst/>
@@ -6078,8 +6078,8 @@
         </p:nvSpPr>
         <p:spPr>
           <a:xfrm>
-            <a:off x="548640" y="2926080"/>
-            <a:ext cx="11155680" cy="3200400"/>
+            <a:off x="365760" y="2926080"/>
+            <a:ext cx="11430000" cy="3200400"/>
           </a:xfrm>
           <a:prstGeom prst="rect">
             <a:avLst/>
@@ -6436,8 +6436,8 @@
         </p:nvSpPr>
         <p:spPr>
           <a:xfrm>
-            <a:off x="548640" y="2926080"/>
-            <a:ext cx="11155680" cy="3200400"/>
+            <a:off x="365760" y="2926080"/>
+            <a:ext cx="11430000" cy="3200400"/>
           </a:xfrm>
           <a:prstGeom prst="rect">
             <a:avLst/>
@@ -6659,8 +6659,8 @@
         </p:nvSpPr>
         <p:spPr>
           <a:xfrm>
-            <a:off x="548640" y="2926080"/>
-            <a:ext cx="11155680" cy="3200400"/>
+            <a:off x="365760" y="2926080"/>
+            <a:ext cx="11430000" cy="3200400"/>
           </a:xfrm>
           <a:prstGeom prst="rect">
             <a:avLst/>
@@ -6882,8 +6882,8 @@
         </p:nvSpPr>
         <p:spPr>
           <a:xfrm>
-            <a:off x="548640" y="2926080"/>
-            <a:ext cx="11155680" cy="3200400"/>
+            <a:off x="365760" y="2926080"/>
+            <a:ext cx="11430000" cy="3200400"/>
           </a:xfrm>
           <a:prstGeom prst="rect">
             <a:avLst/>
@@ -7052,8 +7052,8 @@
         </p:nvSpPr>
         <p:spPr>
           <a:xfrm>
-            <a:off x="548640" y="2286000"/>
-            <a:ext cx="11155680" cy="3657600"/>
+            <a:off x="365760" y="2286000"/>
+            <a:ext cx="11430000" cy="3657600"/>
           </a:xfrm>
           <a:prstGeom prst="rect">
             <a:avLst/>
@@ -7069,9 +7069,9 @@
           <a:p>
             <a:pPr>
               <a:spcAft>
-                <a:spcPts val="2200"/>
+                <a:spcPts val="2000"/>
               </a:spcAft>
-              <a:defRPr sz="2500">
+              <a:defRPr sz="2300">
                 <a:solidFill>
                   <a:srgbClr val="1C1B19"/>
                 </a:solidFill>
@@ -7084,9 +7084,9 @@
           <a:p>
             <a:pPr>
               <a:spcAft>
-                <a:spcPts val="2200"/>
+                <a:spcPts val="2000"/>
               </a:spcAft>
-              <a:defRPr sz="2500">
+              <a:defRPr sz="2300">
                 <a:solidFill>
                   <a:srgbClr val="1C1B19"/>
                 </a:solidFill>
@@ -7099,9 +7099,9 @@
           <a:p>
             <a:pPr>
               <a:spcAft>
-                <a:spcPts val="2200"/>
+                <a:spcPts val="2000"/>
               </a:spcAft>
-              <a:defRPr sz="2500">
+              <a:defRPr sz="2300">
                 <a:solidFill>
                   <a:srgbClr val="1C1B19"/>
                 </a:solidFill>
@@ -7114,9 +7114,9 @@
           <a:p>
             <a:pPr>
               <a:spcAft>
-                <a:spcPts val="2200"/>
+                <a:spcPts val="2000"/>
               </a:spcAft>
-              <a:defRPr sz="2500">
+              <a:defRPr sz="2300">
                 <a:solidFill>
                   <a:srgbClr val="1C1B19"/>
                 </a:solidFill>
@@ -7287,8 +7287,8 @@
         </p:nvSpPr>
         <p:spPr>
           <a:xfrm>
-            <a:off x="548640" y="2926080"/>
-            <a:ext cx="11155680" cy="3200400"/>
+            <a:off x="365760" y="2926080"/>
+            <a:ext cx="11430000" cy="3200400"/>
           </a:xfrm>
           <a:prstGeom prst="rect">
             <a:avLst/>
@@ -7510,8 +7510,8 @@
         </p:nvSpPr>
         <p:spPr>
           <a:xfrm>
-            <a:off x="548640" y="2926080"/>
-            <a:ext cx="11155680" cy="3200400"/>
+            <a:off x="365760" y="2926080"/>
+            <a:ext cx="11430000" cy="3200400"/>
           </a:xfrm>
           <a:prstGeom prst="rect">
             <a:avLst/>
@@ -8735,8 +8735,8 @@
         </p:nvSpPr>
         <p:spPr>
           <a:xfrm>
-            <a:off x="548640" y="2926080"/>
-            <a:ext cx="11155680" cy="3200400"/>
+            <a:off x="365760" y="2926080"/>
+            <a:ext cx="11430000" cy="3200400"/>
           </a:xfrm>
           <a:prstGeom prst="rect">
             <a:avLst/>
@@ -8958,8 +8958,8 @@
         </p:nvSpPr>
         <p:spPr>
           <a:xfrm>
-            <a:off x="548640" y="2926080"/>
-            <a:ext cx="11155680" cy="3200400"/>
+            <a:off x="365760" y="2926080"/>
+            <a:ext cx="11430000" cy="3200400"/>
           </a:xfrm>
           <a:prstGeom prst="rect">
             <a:avLst/>

</xml_diff>